<commit_message>
feat: Add developer touchpoints and traceability gap slides, and identity separation plan
Co-Authored-By: Claude Opus 4.6 <noreply@anthropic.com>
</commit_message>
<xml_diff>
--- a/docs/SDLC-Branch-Traceability-Standards.pptx
+++ b/docs/SDLC-Branch-Traceability-Standards.pptx
@@ -20,6 +20,8 @@
     <p:sldId id="268" r:id="rId19"/>
     <p:sldId id="269" r:id="rId20"/>
     <p:sldId id="270" r:id="rId21"/>
+    <p:sldId id="271" r:id="rId22"/>
+    <p:sldId id="272" r:id="rId23"/>
   </p:sldIdLst>
   <p:sldSz cx="12191695" cy="6858000" type="screen4x3"/>
   <p:notesSz cx="6858000" cy="9144000"/>
@@ -3335,7 +3337,7 @@
               </a:defRPr>
             </a:pPr>
             <a:r>
-              <a:t>1 / 15</a:t>
+              <a:t>1 / 17</a:t>
             </a:r>
           </a:p>
         </p:txBody>
@@ -4352,7 +4354,7 @@
         <p:spPr>
           <a:xfrm>
             <a:off x="6583680" y="4434840"/>
-            <a:ext cx="2011680" cy="320040"/>
+            <a:ext cx="1828800" cy="320040"/>
           </a:xfrm>
           <a:prstGeom prst="rect">
             <a:avLst/>
@@ -4387,8 +4389,8 @@
         </p:nvSpPr>
         <p:spPr>
           <a:xfrm>
-            <a:off x="8595360" y="4434840"/>
-            <a:ext cx="2468880" cy="320040"/>
+            <a:off x="8412480" y="4434840"/>
+            <a:ext cx="2743200" cy="320040"/>
           </a:xfrm>
           <a:prstGeom prst="rect">
             <a:avLst/>
@@ -4424,7 +4426,7 @@
         <p:spPr>
           <a:xfrm>
             <a:off x="6583680" y="4818888"/>
-            <a:ext cx="2011680" cy="320040"/>
+            <a:ext cx="1828800" cy="320040"/>
           </a:xfrm>
           <a:prstGeom prst="rect">
             <a:avLst/>
@@ -4459,8 +4461,8 @@
         </p:nvSpPr>
         <p:spPr>
           <a:xfrm>
-            <a:off x="8595360" y="4818888"/>
-            <a:ext cx="2468880" cy="320040"/>
+            <a:off x="8412480" y="4818888"/>
+            <a:ext cx="2743200" cy="320040"/>
           </a:xfrm>
           <a:prstGeom prst="rect">
             <a:avLst/>
@@ -4482,7 +4484,7 @@
               </a:defRPr>
             </a:pPr>
             <a:r>
-              <a:t>feature/IS-1234-signup-form from main/develop</a:t>
+              <a:t>feature/IS-1234-signup-form</a:t>
             </a:r>
           </a:p>
         </p:txBody>
@@ -4496,7 +4498,7 @@
         <p:spPr>
           <a:xfrm>
             <a:off x="6583680" y="5202936"/>
-            <a:ext cx="2011680" cy="320040"/>
+            <a:ext cx="1828800" cy="320040"/>
           </a:xfrm>
           <a:prstGeom prst="rect">
             <a:avLst/>
@@ -4531,8 +4533,8 @@
         </p:nvSpPr>
         <p:spPr>
           <a:xfrm>
-            <a:off x="8595360" y="5202936"/>
-            <a:ext cx="2468880" cy="320040"/>
+            <a:off x="8412480" y="5202936"/>
+            <a:ext cx="2743200" cy="320040"/>
           </a:xfrm>
           <a:prstGeom prst="rect">
             <a:avLst/>
@@ -4568,7 +4570,7 @@
         <p:spPr>
           <a:xfrm>
             <a:off x="6583680" y="5586984"/>
-            <a:ext cx="2011680" cy="320040"/>
+            <a:ext cx="1828800" cy="320040"/>
           </a:xfrm>
           <a:prstGeom prst="rect">
             <a:avLst/>
@@ -4603,8 +4605,8 @@
         </p:nvSpPr>
         <p:spPr>
           <a:xfrm>
-            <a:off x="8595360" y="5586984"/>
-            <a:ext cx="2468880" cy="320040"/>
+            <a:off x="8412480" y="5586984"/>
+            <a:ext cx="2743200" cy="320040"/>
           </a:xfrm>
           <a:prstGeom prst="rect">
             <a:avLst/>
@@ -4626,7 +4628,7 @@
               </a:defRPr>
             </a:pPr>
             <a:r>
-              <a:t>PR title: feat(auth): IS-1234 Add signup form</a:t>
+              <a:t>feat(auth): IS-1234 Add signup form</a:t>
             </a:r>
           </a:p>
         </p:txBody>
@@ -4640,7 +4642,7 @@
         <p:spPr>
           <a:xfrm>
             <a:off x="6583680" y="5971032"/>
-            <a:ext cx="2011680" cy="320040"/>
+            <a:ext cx="1828800" cy="320040"/>
           </a:xfrm>
           <a:prstGeom prst="rect">
             <a:avLst/>
@@ -4675,8 +4677,8 @@
         </p:nvSpPr>
         <p:spPr>
           <a:xfrm>
-            <a:off x="8595360" y="5971032"/>
-            <a:ext cx="2468880" cy="320040"/>
+            <a:off x="8412480" y="5971032"/>
+            <a:ext cx="2743200" cy="320040"/>
           </a:xfrm>
           <a:prstGeom prst="rect">
             <a:avLst/>
@@ -4698,58 +4700,14 @@
               </a:defRPr>
             </a:pPr>
             <a:r>
-              <a:t>Squash-merge, delete branch, story → Done</a:t>
-            </a:r>
-          </a:p>
-        </p:txBody>
-      </p:sp>
-      <p:sp>
-        <p:nvSpPr>
-          <p:cNvPr id="37" name="Rounded Rectangle 36"/>
-          <p:cNvSpPr/>
-          <p:nvPr/>
-        </p:nvSpPr>
-        <p:spPr>
-          <a:xfrm>
-            <a:off x="6400800" y="6400800"/>
-            <a:ext cx="4663440" cy="0"/>
-          </a:xfrm>
-          <a:prstGeom prst="roundRect">
-            <a:avLst/>
-          </a:prstGeom>
-          <a:solidFill>
-            <a:srgbClr val="26263E"/>
-          </a:solidFill>
-          <a:ln>
-            <a:noFill/>
-          </a:ln>
-          <a:effectLst/>
-        </p:spPr>
-        <p:style>
-          <a:lnRef idx="1">
-            <a:schemeClr val="accent1"/>
-          </a:lnRef>
-          <a:fillRef idx="3">
-            <a:schemeClr val="accent1"/>
-          </a:fillRef>
-          <a:effectRef idx="2">
-            <a:schemeClr val="accent1"/>
-          </a:effectRef>
-          <a:fontRef idx="minor">
-            <a:schemeClr val="lt1"/>
-          </a:fontRef>
-        </p:style>
-        <p:txBody>
-          <a:bodyPr rtlCol="0" anchor="ctr"/>
-          <a:lstStyle/>
-          <a:p>
-            <a:pPr algn="ctr"/>
-          </a:p>
-        </p:txBody>
-      </p:sp>
-      <p:sp>
-        <p:nvSpPr>
-          <p:cNvPr id="38" name="TextBox 37"/>
+              <a:t>Squash-merge, delete branch, done</a:t>
+            </a:r>
+          </a:p>
+        </p:txBody>
+      </p:sp>
+      <p:sp>
+        <p:nvSpPr>
+          <p:cNvPr id="37" name="TextBox 36"/>
           <p:cNvSpPr txBox="1"/>
           <p:nvPr/>
         </p:nvSpPr>
@@ -4778,7 +4736,7 @@
               </a:defRPr>
             </a:pPr>
             <a:r>
-              <a:t>10 / 15</a:t>
+              <a:t>10 / 17</a:t>
             </a:r>
           </a:p>
         </p:txBody>
@@ -6472,7 +6430,7 @@
               </a:defRPr>
             </a:pPr>
             <a:r>
-              <a:t>11 / 15</a:t>
+              <a:t>11 / 17</a:t>
             </a:r>
           </a:p>
         </p:txBody>
@@ -8043,7 +8001,7 @@
               </a:defRPr>
             </a:pPr>
             <a:r>
-              <a:t>12 / 15</a:t>
+              <a:t>12 / 17</a:t>
             </a:r>
           </a:p>
         </p:txBody>
@@ -9922,7 +9880,7 @@
               </a:defRPr>
             </a:pPr>
             <a:r>
-              <a:t>13 / 15</a:t>
+              <a:t>13 / 17</a:t>
             </a:r>
           </a:p>
         </p:txBody>
@@ -11231,7 +11189,7 @@
               </a:defRPr>
             </a:pPr>
             <a:r>
-              <a:t>14 / 15</a:t>
+              <a:t>14 / 17</a:t>
             </a:r>
           </a:p>
         </p:txBody>
@@ -12264,7 +12222,4528 @@
               </a:defRPr>
             </a:pPr>
             <a:r>
-              <a:t>15 / 15</a:t>
+              <a:t>15 / 17</a:t>
+            </a:r>
+          </a:p>
+        </p:txBody>
+      </p:sp>
+    </p:spTree>
+  </p:cSld>
+  <p:clrMapOvr>
+    <a:masterClrMapping/>
+  </p:clrMapOvr>
+</p:sld>
+</file>
+
+<file path=ppt/slides/slide16.xml><?xml version="1.0" encoding="utf-8"?>
+<p:sld xmlns:a="http://schemas.openxmlformats.org/drawingml/2006/main" xmlns:p="http://schemas.openxmlformats.org/presentationml/2006/main" xmlns:r="http://schemas.openxmlformats.org/officeDocument/2006/relationships">
+  <p:cSld>
+    <p:bg>
+      <p:bgPr>
+        <a:solidFill>
+          <a:srgbClr val="1B1B2F"/>
+        </a:solidFill>
+        <a:effectLst/>
+      </p:bgPr>
+    </p:bg>
+    <p:spTree>
+      <p:nvGrpSpPr>
+        <p:cNvPr id="1" name=""/>
+        <p:cNvGrpSpPr/>
+        <p:nvPr/>
+      </p:nvGrpSpPr>
+      <p:grpSpPr/>
+      <p:sp>
+        <p:nvSpPr>
+          <p:cNvPr id="2" name="Rectangle 1"/>
+          <p:cNvSpPr/>
+          <p:nvPr/>
+        </p:nvSpPr>
+        <p:spPr>
+          <a:xfrm>
+            <a:off x="0" y="0"/>
+            <a:ext cx="12191695" cy="54864"/>
+          </a:xfrm>
+          <a:prstGeom prst="rect">
+            <a:avLst/>
+          </a:prstGeom>
+          <a:solidFill>
+            <a:srgbClr val="00C97B"/>
+          </a:solidFill>
+          <a:ln>
+            <a:noFill/>
+          </a:ln>
+        </p:spPr>
+        <p:style>
+          <a:lnRef idx="1">
+            <a:schemeClr val="accent1"/>
+          </a:lnRef>
+          <a:fillRef idx="3">
+            <a:schemeClr val="accent1"/>
+          </a:fillRef>
+          <a:effectRef idx="2">
+            <a:schemeClr val="accent1"/>
+          </a:effectRef>
+          <a:fontRef idx="minor">
+            <a:schemeClr val="lt1"/>
+          </a:fontRef>
+        </p:style>
+        <p:txBody>
+          <a:bodyPr rtlCol="0" anchor="ctr"/>
+          <a:lstStyle/>
+          <a:p>
+            <a:pPr algn="ctr"/>
+          </a:p>
+        </p:txBody>
+      </p:sp>
+      <p:sp>
+        <p:nvSpPr>
+          <p:cNvPr id="3" name="TextBox 2"/>
+          <p:cNvSpPr txBox="1"/>
+          <p:nvPr/>
+        </p:nvSpPr>
+        <p:spPr>
+          <a:xfrm>
+            <a:off x="731520" y="365760"/>
+            <a:ext cx="9144000" cy="640080"/>
+          </a:xfrm>
+          <a:prstGeom prst="rect">
+            <a:avLst/>
+          </a:prstGeom>
+          <a:noFill/>
+        </p:spPr>
+        <p:txBody>
+          <a:bodyPr wrap="square">
+            <a:spAutoFit/>
+          </a:bodyPr>
+          <a:lstStyle/>
+          <a:p>
+            <a:pPr algn="l">
+              <a:defRPr sz="3200" b="1">
+                <a:solidFill>
+                  <a:srgbClr val="FFFFFF"/>
+                </a:solidFill>
+                <a:latin typeface="Calibri"/>
+              </a:defRPr>
+            </a:pPr>
+            <a:r>
+              <a:t>Developer Touchpoints for Traceability</a:t>
+            </a:r>
+          </a:p>
+        </p:txBody>
+      </p:sp>
+      <p:sp>
+        <p:nvSpPr>
+          <p:cNvPr id="4" name="TextBox 3"/>
+          <p:cNvSpPr txBox="1"/>
+          <p:nvPr/>
+        </p:nvSpPr>
+        <p:spPr>
+          <a:xfrm>
+            <a:off x="731520" y="914400"/>
+            <a:ext cx="9144000" cy="457200"/>
+          </a:xfrm>
+          <a:prstGeom prst="rect">
+            <a:avLst/>
+          </a:prstGeom>
+          <a:noFill/>
+        </p:spPr>
+        <p:txBody>
+          <a:bodyPr wrap="square">
+            <a:spAutoFit/>
+          </a:bodyPr>
+          <a:lstStyle/>
+          <a:p>
+            <a:pPr algn="l">
+              <a:defRPr sz="1400" b="0">
+                <a:solidFill>
+                  <a:srgbClr val="888899"/>
+                </a:solidFill>
+                <a:latin typeface="Calibri"/>
+              </a:defRPr>
+            </a:pPr>
+            <a:r>
+              <a:t>Only 2 manual steps required from developers — automation handles the rest</a:t>
+            </a:r>
+          </a:p>
+        </p:txBody>
+      </p:sp>
+      <p:sp>
+        <p:nvSpPr>
+          <p:cNvPr id="5" name="Rounded Rectangle 4"/>
+          <p:cNvSpPr/>
+          <p:nvPr/>
+        </p:nvSpPr>
+        <p:spPr>
+          <a:xfrm>
+            <a:off x="731520" y="1371600"/>
+            <a:ext cx="6858000" cy="5212080"/>
+          </a:xfrm>
+          <a:prstGeom prst="roundRect">
+            <a:avLst/>
+          </a:prstGeom>
+          <a:solidFill>
+            <a:srgbClr val="26263E"/>
+          </a:solidFill>
+          <a:ln>
+            <a:noFill/>
+          </a:ln>
+          <a:effectLst/>
+        </p:spPr>
+        <p:style>
+          <a:lnRef idx="1">
+            <a:schemeClr val="accent1"/>
+          </a:lnRef>
+          <a:fillRef idx="3">
+            <a:schemeClr val="accent1"/>
+          </a:fillRef>
+          <a:effectRef idx="2">
+            <a:schemeClr val="accent1"/>
+          </a:effectRef>
+          <a:fontRef idx="minor">
+            <a:schemeClr val="lt1"/>
+          </a:fontRef>
+        </p:style>
+        <p:txBody>
+          <a:bodyPr rtlCol="0" anchor="ctr"/>
+          <a:lstStyle/>
+          <a:p>
+            <a:pPr algn="ctr"/>
+          </a:p>
+        </p:txBody>
+      </p:sp>
+      <p:sp>
+        <p:nvSpPr>
+          <p:cNvPr id="6" name="Rectangle 5"/>
+          <p:cNvSpPr/>
+          <p:nvPr/>
+        </p:nvSpPr>
+        <p:spPr>
+          <a:xfrm>
+            <a:off x="731520" y="1371600"/>
+            <a:ext cx="73152" cy="5212080"/>
+          </a:xfrm>
+          <a:prstGeom prst="rect">
+            <a:avLst/>
+          </a:prstGeom>
+          <a:solidFill>
+            <a:srgbClr val="00C97B"/>
+          </a:solidFill>
+          <a:ln>
+            <a:noFill/>
+          </a:ln>
+        </p:spPr>
+        <p:style>
+          <a:lnRef idx="1">
+            <a:schemeClr val="accent1"/>
+          </a:lnRef>
+          <a:fillRef idx="3">
+            <a:schemeClr val="accent1"/>
+          </a:fillRef>
+          <a:effectRef idx="2">
+            <a:schemeClr val="accent1"/>
+          </a:effectRef>
+          <a:fontRef idx="minor">
+            <a:schemeClr val="lt1"/>
+          </a:fontRef>
+        </p:style>
+        <p:txBody>
+          <a:bodyPr rtlCol="0" anchor="ctr"/>
+          <a:lstStyle/>
+          <a:p>
+            <a:pPr algn="ctr"/>
+          </a:p>
+        </p:txBody>
+      </p:sp>
+      <p:sp>
+        <p:nvSpPr>
+          <p:cNvPr id="7" name="TextBox 6"/>
+          <p:cNvSpPr txBox="1"/>
+          <p:nvPr/>
+        </p:nvSpPr>
+        <p:spPr>
+          <a:xfrm>
+            <a:off x="1097280" y="1463040"/>
+            <a:ext cx="6217920" cy="365760"/>
+          </a:xfrm>
+          <a:prstGeom prst="rect">
+            <a:avLst/>
+          </a:prstGeom>
+          <a:noFill/>
+        </p:spPr>
+        <p:txBody>
+          <a:bodyPr wrap="square">
+            <a:spAutoFit/>
+          </a:bodyPr>
+          <a:lstStyle/>
+          <a:p>
+            <a:pPr algn="l">
+              <a:defRPr sz="1600" b="1">
+                <a:solidFill>
+                  <a:srgbClr val="00C97B"/>
+                </a:solidFill>
+                <a:latin typeface="Calibri"/>
+              </a:defRPr>
+            </a:pPr>
+            <a:r>
+              <a:t>WHAT YOU DO  (2 manual steps)</a:t>
+            </a:r>
+          </a:p>
+        </p:txBody>
+      </p:sp>
+      <p:sp>
+        <p:nvSpPr>
+          <p:cNvPr id="8" name="Rounded Rectangle 7"/>
+          <p:cNvSpPr/>
+          <p:nvPr/>
+        </p:nvSpPr>
+        <p:spPr>
+          <a:xfrm>
+            <a:off x="1097280" y="1965960"/>
+            <a:ext cx="411480" cy="411480"/>
+          </a:xfrm>
+          <a:prstGeom prst="roundRect">
+            <a:avLst/>
+          </a:prstGeom>
+          <a:solidFill>
+            <a:srgbClr val="00C97B"/>
+          </a:solidFill>
+          <a:ln>
+            <a:noFill/>
+          </a:ln>
+          <a:effectLst/>
+        </p:spPr>
+        <p:style>
+          <a:lnRef idx="1">
+            <a:schemeClr val="accent1"/>
+          </a:lnRef>
+          <a:fillRef idx="3">
+            <a:schemeClr val="accent1"/>
+          </a:fillRef>
+          <a:effectRef idx="2">
+            <a:schemeClr val="accent1"/>
+          </a:effectRef>
+          <a:fontRef idx="minor">
+            <a:schemeClr val="lt1"/>
+          </a:fontRef>
+        </p:style>
+        <p:txBody>
+          <a:bodyPr rtlCol="0" anchor="ctr"/>
+          <a:lstStyle/>
+          <a:p>
+            <a:pPr algn="ctr"/>
+          </a:p>
+        </p:txBody>
+      </p:sp>
+      <p:sp>
+        <p:nvSpPr>
+          <p:cNvPr id="9" name="TextBox 8"/>
+          <p:cNvSpPr txBox="1"/>
+          <p:nvPr/>
+        </p:nvSpPr>
+        <p:spPr>
+          <a:xfrm>
+            <a:off x="1097280" y="1984248"/>
+            <a:ext cx="411480" cy="365760"/>
+          </a:xfrm>
+          <a:prstGeom prst="rect">
+            <a:avLst/>
+          </a:prstGeom>
+          <a:noFill/>
+        </p:spPr>
+        <p:txBody>
+          <a:bodyPr wrap="square">
+            <a:spAutoFit/>
+          </a:bodyPr>
+          <a:lstStyle/>
+          <a:p>
+            <a:pPr algn="ctr">
+              <a:defRPr sz="1800" b="1">
+                <a:solidFill>
+                  <a:srgbClr val="FFFFFF"/>
+                </a:solidFill>
+                <a:latin typeface="Calibri"/>
+              </a:defRPr>
+            </a:pPr>
+            <a:r>
+              <a:t>1</a:t>
+            </a:r>
+          </a:p>
+        </p:txBody>
+      </p:sp>
+      <p:sp>
+        <p:nvSpPr>
+          <p:cNvPr id="10" name="TextBox 9"/>
+          <p:cNvSpPr txBox="1"/>
+          <p:nvPr/>
+        </p:nvSpPr>
+        <p:spPr>
+          <a:xfrm>
+            <a:off x="1645920" y="1965960"/>
+            <a:ext cx="5669280" cy="411480"/>
+          </a:xfrm>
+          <a:prstGeom prst="rect">
+            <a:avLst/>
+          </a:prstGeom>
+          <a:noFill/>
+        </p:spPr>
+        <p:txBody>
+          <a:bodyPr wrap="square">
+            <a:spAutoFit/>
+          </a:bodyPr>
+          <a:lstStyle/>
+          <a:p>
+            <a:pPr algn="l">
+              <a:defRPr sz="1600" b="1">
+                <a:solidFill>
+                  <a:srgbClr val="FFFFFF"/>
+                </a:solidFill>
+                <a:latin typeface="Calibri"/>
+              </a:defRPr>
+            </a:pPr>
+            <a:r>
+              <a:t>Include the ticket ID in your branch name</a:t>
+            </a:r>
+          </a:p>
+        </p:txBody>
+      </p:sp>
+      <p:sp>
+        <p:nvSpPr>
+          <p:cNvPr id="11" name="TextBox 10"/>
+          <p:cNvSpPr txBox="1"/>
+          <p:nvPr/>
+        </p:nvSpPr>
+        <p:spPr>
+          <a:xfrm>
+            <a:off x="1371600" y="2514600"/>
+            <a:ext cx="1188720" cy="274320"/>
+          </a:xfrm>
+          <a:prstGeom prst="rect">
+            <a:avLst/>
+          </a:prstGeom>
+          <a:noFill/>
+        </p:spPr>
+        <p:txBody>
+          <a:bodyPr wrap="square">
+            <a:spAutoFit/>
+          </a:bodyPr>
+          <a:lstStyle/>
+          <a:p>
+            <a:pPr algn="l">
+              <a:defRPr sz="1000" b="1">
+                <a:solidFill>
+                  <a:srgbClr val="008CFF"/>
+                </a:solidFill>
+                <a:latin typeface="Calibri"/>
+              </a:defRPr>
+            </a:pPr>
+            <a:r>
+              <a:t>TYPE</a:t>
+            </a:r>
+          </a:p>
+        </p:txBody>
+      </p:sp>
+      <p:sp>
+        <p:nvSpPr>
+          <p:cNvPr id="12" name="TextBox 11"/>
+          <p:cNvSpPr txBox="1"/>
+          <p:nvPr/>
+        </p:nvSpPr>
+        <p:spPr>
+          <a:xfrm>
+            <a:off x="2560320" y="2514600"/>
+            <a:ext cx="914400" cy="274320"/>
+          </a:xfrm>
+          <a:prstGeom prst="rect">
+            <a:avLst/>
+          </a:prstGeom>
+          <a:noFill/>
+        </p:spPr>
+        <p:txBody>
+          <a:bodyPr wrap="square">
+            <a:spAutoFit/>
+          </a:bodyPr>
+          <a:lstStyle/>
+          <a:p>
+            <a:pPr algn="l">
+              <a:defRPr sz="1000" b="1">
+                <a:solidFill>
+                  <a:srgbClr val="008CFF"/>
+                </a:solidFill>
+                <a:latin typeface="Calibri"/>
+              </a:defRPr>
+            </a:pPr>
+            <a:r>
+              <a:t>ID</a:t>
+            </a:r>
+          </a:p>
+        </p:txBody>
+      </p:sp>
+      <p:sp>
+        <p:nvSpPr>
+          <p:cNvPr id="13" name="TextBox 12"/>
+          <p:cNvSpPr txBox="1"/>
+          <p:nvPr/>
+        </p:nvSpPr>
+        <p:spPr>
+          <a:xfrm>
+            <a:off x="3474720" y="2514600"/>
+            <a:ext cx="1097280" cy="274320"/>
+          </a:xfrm>
+          <a:prstGeom prst="rect">
+            <a:avLst/>
+          </a:prstGeom>
+          <a:noFill/>
+        </p:spPr>
+        <p:txBody>
+          <a:bodyPr wrap="square">
+            <a:spAutoFit/>
+          </a:bodyPr>
+          <a:lstStyle/>
+          <a:p>
+            <a:pPr algn="l">
+              <a:defRPr sz="1000" b="1">
+                <a:solidFill>
+                  <a:srgbClr val="008CFF"/>
+                </a:solidFill>
+                <a:latin typeface="Calibri"/>
+              </a:defRPr>
+            </a:pPr>
+            <a:r>
+              <a:t>SOURCE</a:t>
+            </a:r>
+          </a:p>
+        </p:txBody>
+      </p:sp>
+      <p:sp>
+        <p:nvSpPr>
+          <p:cNvPr id="14" name="TextBox 13"/>
+          <p:cNvSpPr txBox="1"/>
+          <p:nvPr/>
+        </p:nvSpPr>
+        <p:spPr>
+          <a:xfrm>
+            <a:off x="4754880" y="2514600"/>
+            <a:ext cx="2743200" cy="274320"/>
+          </a:xfrm>
+          <a:prstGeom prst="rect">
+            <a:avLst/>
+          </a:prstGeom>
+          <a:noFill/>
+        </p:spPr>
+        <p:txBody>
+          <a:bodyPr wrap="square">
+            <a:spAutoFit/>
+          </a:bodyPr>
+          <a:lstStyle/>
+          <a:p>
+            <a:pPr algn="l">
+              <a:defRPr sz="1000" b="1">
+                <a:solidFill>
+                  <a:srgbClr val="008CFF"/>
+                </a:solidFill>
+                <a:latin typeface="Calibri"/>
+              </a:defRPr>
+            </a:pPr>
+            <a:r>
+              <a:t>EXAMPLE</a:t>
+            </a:r>
+          </a:p>
+        </p:txBody>
+      </p:sp>
+      <p:sp>
+        <p:nvSpPr>
+          <p:cNvPr id="15" name="Rectangle 14"/>
+          <p:cNvSpPr/>
+          <p:nvPr/>
+        </p:nvSpPr>
+        <p:spPr>
+          <a:xfrm>
+            <a:off x="1371600" y="2770632"/>
+            <a:ext cx="5943600" cy="18288"/>
+          </a:xfrm>
+          <a:prstGeom prst="rect">
+            <a:avLst/>
+          </a:prstGeom>
+          <a:solidFill>
+            <a:srgbClr val="26263E"/>
+          </a:solidFill>
+          <a:ln>
+            <a:noFill/>
+          </a:ln>
+        </p:spPr>
+        <p:style>
+          <a:lnRef idx="1">
+            <a:schemeClr val="accent1"/>
+          </a:lnRef>
+          <a:fillRef idx="3">
+            <a:schemeClr val="accent1"/>
+          </a:fillRef>
+          <a:effectRef idx="2">
+            <a:schemeClr val="accent1"/>
+          </a:effectRef>
+          <a:fontRef idx="minor">
+            <a:schemeClr val="lt1"/>
+          </a:fontRef>
+        </p:style>
+        <p:txBody>
+          <a:bodyPr rtlCol="0" anchor="ctr"/>
+          <a:lstStyle/>
+          <a:p>
+            <a:pPr algn="ctr"/>
+          </a:p>
+        </p:txBody>
+      </p:sp>
+      <p:sp>
+        <p:nvSpPr>
+          <p:cNvPr id="16" name="Rounded Rectangle 15"/>
+          <p:cNvSpPr/>
+          <p:nvPr/>
+        </p:nvSpPr>
+        <p:spPr>
+          <a:xfrm>
+            <a:off x="1280160" y="2834640"/>
+            <a:ext cx="6126480" cy="329184"/>
+          </a:xfrm>
+          <a:prstGeom prst="roundRect">
+            <a:avLst/>
+          </a:prstGeom>
+          <a:solidFill>
+            <a:srgbClr val="26263E"/>
+          </a:solidFill>
+          <a:ln>
+            <a:noFill/>
+          </a:ln>
+          <a:effectLst/>
+        </p:spPr>
+        <p:style>
+          <a:lnRef idx="1">
+            <a:schemeClr val="accent1"/>
+          </a:lnRef>
+          <a:fillRef idx="3">
+            <a:schemeClr val="accent1"/>
+          </a:fillRef>
+          <a:effectRef idx="2">
+            <a:schemeClr val="accent1"/>
+          </a:effectRef>
+          <a:fontRef idx="minor">
+            <a:schemeClr val="lt1"/>
+          </a:fontRef>
+        </p:style>
+        <p:txBody>
+          <a:bodyPr rtlCol="0" anchor="ctr"/>
+          <a:lstStyle/>
+          <a:p>
+            <a:pPr algn="ctr"/>
+          </a:p>
+        </p:txBody>
+      </p:sp>
+      <p:sp>
+        <p:nvSpPr>
+          <p:cNvPr id="17" name="TextBox 16"/>
+          <p:cNvSpPr txBox="1"/>
+          <p:nvPr/>
+        </p:nvSpPr>
+        <p:spPr>
+          <a:xfrm>
+            <a:off x="1371600" y="2862072"/>
+            <a:ext cx="1188720" cy="274320"/>
+          </a:xfrm>
+          <a:prstGeom prst="rect">
+            <a:avLst/>
+          </a:prstGeom>
+          <a:noFill/>
+        </p:spPr>
+        <p:txBody>
+          <a:bodyPr wrap="square">
+            <a:spAutoFit/>
+          </a:bodyPr>
+          <a:lstStyle/>
+          <a:p>
+            <a:pPr algn="l">
+              <a:defRPr sz="1100" b="1">
+                <a:solidFill>
+                  <a:srgbClr val="008CFF"/>
+                </a:solidFill>
+                <a:latin typeface="Consolas"/>
+              </a:defRPr>
+            </a:pPr>
+            <a:r>
+              <a:t>feature/</a:t>
+            </a:r>
+          </a:p>
+        </p:txBody>
+      </p:sp>
+      <p:sp>
+        <p:nvSpPr>
+          <p:cNvPr id="18" name="TextBox 17"/>
+          <p:cNvSpPr txBox="1"/>
+          <p:nvPr/>
+        </p:nvSpPr>
+        <p:spPr>
+          <a:xfrm>
+            <a:off x="2560320" y="2862072"/>
+            <a:ext cx="914400" cy="274320"/>
+          </a:xfrm>
+          <a:prstGeom prst="rect">
+            <a:avLst/>
+          </a:prstGeom>
+          <a:noFill/>
+        </p:spPr>
+        <p:txBody>
+          <a:bodyPr wrap="square">
+            <a:spAutoFit/>
+          </a:bodyPr>
+          <a:lstStyle/>
+          <a:p>
+            <a:pPr algn="l">
+              <a:defRPr sz="1100" b="0">
+                <a:solidFill>
+                  <a:srgbClr val="FFFFFF"/>
+                </a:solidFill>
+                <a:latin typeface="Consolas"/>
+              </a:defRPr>
+            </a:pPr>
+            <a:r>
+              <a:t>IS-1234</a:t>
+            </a:r>
+          </a:p>
+        </p:txBody>
+      </p:sp>
+      <p:sp>
+        <p:nvSpPr>
+          <p:cNvPr id="19" name="TextBox 18"/>
+          <p:cNvSpPr txBox="1"/>
+          <p:nvPr/>
+        </p:nvSpPr>
+        <p:spPr>
+          <a:xfrm>
+            <a:off x="3474720" y="2862072"/>
+            <a:ext cx="1097280" cy="274320"/>
+          </a:xfrm>
+          <a:prstGeom prst="rect">
+            <a:avLst/>
+          </a:prstGeom>
+          <a:noFill/>
+        </p:spPr>
+        <p:txBody>
+          <a:bodyPr wrap="square">
+            <a:spAutoFit/>
+          </a:bodyPr>
+          <a:lstStyle/>
+          <a:p>
+            <a:pPr algn="l">
+              <a:defRPr sz="1000" b="0">
+                <a:solidFill>
+                  <a:srgbClr val="BBBBCC"/>
+                </a:solidFill>
+                <a:latin typeface="Calibri"/>
+              </a:defRPr>
+            </a:pPr>
+            <a:r>
+              <a:t>User story ID</a:t>
+            </a:r>
+          </a:p>
+        </p:txBody>
+      </p:sp>
+      <p:sp>
+        <p:nvSpPr>
+          <p:cNvPr id="20" name="TextBox 19"/>
+          <p:cNvSpPr txBox="1"/>
+          <p:nvPr/>
+        </p:nvSpPr>
+        <p:spPr>
+          <a:xfrm>
+            <a:off x="4754880" y="2862072"/>
+            <a:ext cx="2743200" cy="274320"/>
+          </a:xfrm>
+          <a:prstGeom prst="rect">
+            <a:avLst/>
+          </a:prstGeom>
+          <a:noFill/>
+        </p:spPr>
+        <p:txBody>
+          <a:bodyPr wrap="square">
+            <a:spAutoFit/>
+          </a:bodyPr>
+          <a:lstStyle/>
+          <a:p>
+            <a:pPr algn="l">
+              <a:defRPr sz="1000" b="0">
+                <a:solidFill>
+                  <a:srgbClr val="FFFFFF"/>
+                </a:solidFill>
+                <a:latin typeface="Consolas"/>
+              </a:defRPr>
+            </a:pPr>
+            <a:r>
+              <a:t>feature/IS-1234-add-profile</a:t>
+            </a:r>
+          </a:p>
+        </p:txBody>
+      </p:sp>
+      <p:sp>
+        <p:nvSpPr>
+          <p:cNvPr id="21" name="TextBox 20"/>
+          <p:cNvSpPr txBox="1"/>
+          <p:nvPr/>
+        </p:nvSpPr>
+        <p:spPr>
+          <a:xfrm>
+            <a:off x="1371600" y="3209544"/>
+            <a:ext cx="1188720" cy="274320"/>
+          </a:xfrm>
+          <a:prstGeom prst="rect">
+            <a:avLst/>
+          </a:prstGeom>
+          <a:noFill/>
+        </p:spPr>
+        <p:txBody>
+          <a:bodyPr wrap="square">
+            <a:spAutoFit/>
+          </a:bodyPr>
+          <a:lstStyle/>
+          <a:p>
+            <a:pPr algn="l">
+              <a:defRPr sz="1100" b="1">
+                <a:solidFill>
+                  <a:srgbClr val="A85CFF"/>
+                </a:solidFill>
+                <a:latin typeface="Consolas"/>
+              </a:defRPr>
+            </a:pPr>
+            <a:r>
+              <a:t>integration/</a:t>
+            </a:r>
+          </a:p>
+        </p:txBody>
+      </p:sp>
+      <p:sp>
+        <p:nvSpPr>
+          <p:cNvPr id="22" name="TextBox 21"/>
+          <p:cNvSpPr txBox="1"/>
+          <p:nvPr/>
+        </p:nvSpPr>
+        <p:spPr>
+          <a:xfrm>
+            <a:off x="2560320" y="3209544"/>
+            <a:ext cx="914400" cy="274320"/>
+          </a:xfrm>
+          <a:prstGeom prst="rect">
+            <a:avLst/>
+          </a:prstGeom>
+          <a:noFill/>
+        </p:spPr>
+        <p:txBody>
+          <a:bodyPr wrap="square">
+            <a:spAutoFit/>
+          </a:bodyPr>
+          <a:lstStyle/>
+          <a:p>
+            <a:pPr algn="l">
+              <a:defRPr sz="1100" b="0">
+                <a:solidFill>
+                  <a:srgbClr val="FFFFFF"/>
+                </a:solidFill>
+                <a:latin typeface="Consolas"/>
+              </a:defRPr>
+            </a:pPr>
+            <a:r>
+              <a:t>IS-200</a:t>
+            </a:r>
+          </a:p>
+        </p:txBody>
+      </p:sp>
+      <p:sp>
+        <p:nvSpPr>
+          <p:cNvPr id="23" name="TextBox 22"/>
+          <p:cNvSpPr txBox="1"/>
+          <p:nvPr/>
+        </p:nvSpPr>
+        <p:spPr>
+          <a:xfrm>
+            <a:off x="3474720" y="3209544"/>
+            <a:ext cx="1097280" cy="274320"/>
+          </a:xfrm>
+          <a:prstGeom prst="rect">
+            <a:avLst/>
+          </a:prstGeom>
+          <a:noFill/>
+        </p:spPr>
+        <p:txBody>
+          <a:bodyPr wrap="square">
+            <a:spAutoFit/>
+          </a:bodyPr>
+          <a:lstStyle/>
+          <a:p>
+            <a:pPr algn="l">
+              <a:defRPr sz="1000" b="0">
+                <a:solidFill>
+                  <a:srgbClr val="BBBBCC"/>
+                </a:solidFill>
+                <a:latin typeface="Calibri"/>
+              </a:defRPr>
+            </a:pPr>
+            <a:r>
+              <a:t>Feature ID</a:t>
+            </a:r>
+          </a:p>
+        </p:txBody>
+      </p:sp>
+      <p:sp>
+        <p:nvSpPr>
+          <p:cNvPr id="24" name="TextBox 23"/>
+          <p:cNvSpPr txBox="1"/>
+          <p:nvPr/>
+        </p:nvSpPr>
+        <p:spPr>
+          <a:xfrm>
+            <a:off x="4754880" y="3209544"/>
+            <a:ext cx="2743200" cy="274320"/>
+          </a:xfrm>
+          <a:prstGeom prst="rect">
+            <a:avLst/>
+          </a:prstGeom>
+          <a:noFill/>
+        </p:spPr>
+        <p:txBody>
+          <a:bodyPr wrap="square">
+            <a:spAutoFit/>
+          </a:bodyPr>
+          <a:lstStyle/>
+          <a:p>
+            <a:pPr algn="l">
+              <a:defRPr sz="1000" b="0">
+                <a:solidFill>
+                  <a:srgbClr val="FFFFFF"/>
+                </a:solidFill>
+                <a:latin typeface="Consolas"/>
+              </a:defRPr>
+            </a:pPr>
+            <a:r>
+              <a:t>integration/IS-200-onboarding</a:t>
+            </a:r>
+          </a:p>
+        </p:txBody>
+      </p:sp>
+      <p:sp>
+        <p:nvSpPr>
+          <p:cNvPr id="25" name="Rounded Rectangle 24"/>
+          <p:cNvSpPr/>
+          <p:nvPr/>
+        </p:nvSpPr>
+        <p:spPr>
+          <a:xfrm>
+            <a:off x="1280160" y="3529584"/>
+            <a:ext cx="6126480" cy="329184"/>
+          </a:xfrm>
+          <a:prstGeom prst="roundRect">
+            <a:avLst/>
+          </a:prstGeom>
+          <a:solidFill>
+            <a:srgbClr val="26263E"/>
+          </a:solidFill>
+          <a:ln>
+            <a:noFill/>
+          </a:ln>
+          <a:effectLst/>
+        </p:spPr>
+        <p:style>
+          <a:lnRef idx="1">
+            <a:schemeClr val="accent1"/>
+          </a:lnRef>
+          <a:fillRef idx="3">
+            <a:schemeClr val="accent1"/>
+          </a:fillRef>
+          <a:effectRef idx="2">
+            <a:schemeClr val="accent1"/>
+          </a:effectRef>
+          <a:fontRef idx="minor">
+            <a:schemeClr val="lt1"/>
+          </a:fontRef>
+        </p:style>
+        <p:txBody>
+          <a:bodyPr rtlCol="0" anchor="ctr"/>
+          <a:lstStyle/>
+          <a:p>
+            <a:pPr algn="ctr"/>
+          </a:p>
+        </p:txBody>
+      </p:sp>
+      <p:sp>
+        <p:nvSpPr>
+          <p:cNvPr id="26" name="TextBox 25"/>
+          <p:cNvSpPr txBox="1"/>
+          <p:nvPr/>
+        </p:nvSpPr>
+        <p:spPr>
+          <a:xfrm>
+            <a:off x="1371600" y="3557016"/>
+            <a:ext cx="1188720" cy="274320"/>
+          </a:xfrm>
+          <a:prstGeom prst="rect">
+            <a:avLst/>
+          </a:prstGeom>
+          <a:noFill/>
+        </p:spPr>
+        <p:txBody>
+          <a:bodyPr wrap="square">
+            <a:spAutoFit/>
+          </a:bodyPr>
+          <a:lstStyle/>
+          <a:p>
+            <a:pPr algn="l">
+              <a:defRPr sz="1100" b="1">
+                <a:solidFill>
+                  <a:srgbClr val="FF8C00"/>
+                </a:solidFill>
+                <a:latin typeface="Consolas"/>
+              </a:defRPr>
+            </a:pPr>
+            <a:r>
+              <a:t>bugfix/</a:t>
+            </a:r>
+          </a:p>
+        </p:txBody>
+      </p:sp>
+      <p:sp>
+        <p:nvSpPr>
+          <p:cNvPr id="27" name="TextBox 26"/>
+          <p:cNvSpPr txBox="1"/>
+          <p:nvPr/>
+        </p:nvSpPr>
+        <p:spPr>
+          <a:xfrm>
+            <a:off x="2560320" y="3557016"/>
+            <a:ext cx="914400" cy="274320"/>
+          </a:xfrm>
+          <a:prstGeom prst="rect">
+            <a:avLst/>
+          </a:prstGeom>
+          <a:noFill/>
+        </p:spPr>
+        <p:txBody>
+          <a:bodyPr wrap="square">
+            <a:spAutoFit/>
+          </a:bodyPr>
+          <a:lstStyle/>
+          <a:p>
+            <a:pPr algn="l">
+              <a:defRPr sz="1100" b="0">
+                <a:solidFill>
+                  <a:srgbClr val="FFFFFF"/>
+                </a:solidFill>
+                <a:latin typeface="Consolas"/>
+              </a:defRPr>
+            </a:pPr>
+            <a:r>
+              <a:t>IS-567</a:t>
+            </a:r>
+          </a:p>
+        </p:txBody>
+      </p:sp>
+      <p:sp>
+        <p:nvSpPr>
+          <p:cNvPr id="28" name="TextBox 27"/>
+          <p:cNvSpPr txBox="1"/>
+          <p:nvPr/>
+        </p:nvSpPr>
+        <p:spPr>
+          <a:xfrm>
+            <a:off x="3474720" y="3557016"/>
+            <a:ext cx="1097280" cy="274320"/>
+          </a:xfrm>
+          <a:prstGeom prst="rect">
+            <a:avLst/>
+          </a:prstGeom>
+          <a:noFill/>
+        </p:spPr>
+        <p:txBody>
+          <a:bodyPr wrap="square">
+            <a:spAutoFit/>
+          </a:bodyPr>
+          <a:lstStyle/>
+          <a:p>
+            <a:pPr algn="l">
+              <a:defRPr sz="1000" b="0">
+                <a:solidFill>
+                  <a:srgbClr val="BBBBCC"/>
+                </a:solidFill>
+                <a:latin typeface="Calibri"/>
+              </a:defRPr>
+            </a:pPr>
+            <a:r>
+              <a:t>Defect ID</a:t>
+            </a:r>
+          </a:p>
+        </p:txBody>
+      </p:sp>
+      <p:sp>
+        <p:nvSpPr>
+          <p:cNvPr id="29" name="TextBox 28"/>
+          <p:cNvSpPr txBox="1"/>
+          <p:nvPr/>
+        </p:nvSpPr>
+        <p:spPr>
+          <a:xfrm>
+            <a:off x="4754880" y="3557016"/>
+            <a:ext cx="2743200" cy="274320"/>
+          </a:xfrm>
+          <a:prstGeom prst="rect">
+            <a:avLst/>
+          </a:prstGeom>
+          <a:noFill/>
+        </p:spPr>
+        <p:txBody>
+          <a:bodyPr wrap="square">
+            <a:spAutoFit/>
+          </a:bodyPr>
+          <a:lstStyle/>
+          <a:p>
+            <a:pPr algn="l">
+              <a:defRPr sz="1000" b="0">
+                <a:solidFill>
+                  <a:srgbClr val="FFFFFF"/>
+                </a:solidFill>
+                <a:latin typeface="Consolas"/>
+              </a:defRPr>
+            </a:pPr>
+            <a:r>
+              <a:t>bugfix/IS-567-fix-login-timeout</a:t>
+            </a:r>
+          </a:p>
+        </p:txBody>
+      </p:sp>
+      <p:sp>
+        <p:nvSpPr>
+          <p:cNvPr id="30" name="TextBox 29"/>
+          <p:cNvSpPr txBox="1"/>
+          <p:nvPr/>
+        </p:nvSpPr>
+        <p:spPr>
+          <a:xfrm>
+            <a:off x="1371600" y="3904488"/>
+            <a:ext cx="1188720" cy="274320"/>
+          </a:xfrm>
+          <a:prstGeom prst="rect">
+            <a:avLst/>
+          </a:prstGeom>
+          <a:noFill/>
+        </p:spPr>
+        <p:txBody>
+          <a:bodyPr wrap="square">
+            <a:spAutoFit/>
+          </a:bodyPr>
+          <a:lstStyle/>
+          <a:p>
+            <a:pPr algn="l">
+              <a:defRPr sz="1100" b="1">
+                <a:solidFill>
+                  <a:srgbClr val="FF4545"/>
+                </a:solidFill>
+                <a:latin typeface="Consolas"/>
+              </a:defRPr>
+            </a:pPr>
+            <a:r>
+              <a:t>hotfix/</a:t>
+            </a:r>
+          </a:p>
+        </p:txBody>
+      </p:sp>
+      <p:sp>
+        <p:nvSpPr>
+          <p:cNvPr id="31" name="TextBox 30"/>
+          <p:cNvSpPr txBox="1"/>
+          <p:nvPr/>
+        </p:nvSpPr>
+        <p:spPr>
+          <a:xfrm>
+            <a:off x="2560320" y="3904488"/>
+            <a:ext cx="914400" cy="274320"/>
+          </a:xfrm>
+          <a:prstGeom prst="rect">
+            <a:avLst/>
+          </a:prstGeom>
+          <a:noFill/>
+        </p:spPr>
+        <p:txBody>
+          <a:bodyPr wrap="square">
+            <a:spAutoFit/>
+          </a:bodyPr>
+          <a:lstStyle/>
+          <a:p>
+            <a:pPr algn="l">
+              <a:defRPr sz="1100" b="0">
+                <a:solidFill>
+                  <a:srgbClr val="FFFFFF"/>
+                </a:solidFill>
+                <a:latin typeface="Consolas"/>
+              </a:defRPr>
+            </a:pPr>
+            <a:r>
+              <a:t>IS-890</a:t>
+            </a:r>
+          </a:p>
+        </p:txBody>
+      </p:sp>
+      <p:sp>
+        <p:nvSpPr>
+          <p:cNvPr id="32" name="TextBox 31"/>
+          <p:cNvSpPr txBox="1"/>
+          <p:nvPr/>
+        </p:nvSpPr>
+        <p:spPr>
+          <a:xfrm>
+            <a:off x="3474720" y="3904488"/>
+            <a:ext cx="1097280" cy="274320"/>
+          </a:xfrm>
+          <a:prstGeom prst="rect">
+            <a:avLst/>
+          </a:prstGeom>
+          <a:noFill/>
+        </p:spPr>
+        <p:txBody>
+          <a:bodyPr wrap="square">
+            <a:spAutoFit/>
+          </a:bodyPr>
+          <a:lstStyle/>
+          <a:p>
+            <a:pPr algn="l">
+              <a:defRPr sz="1000" b="0">
+                <a:solidFill>
+                  <a:srgbClr val="BBBBCC"/>
+                </a:solidFill>
+                <a:latin typeface="Calibri"/>
+              </a:defRPr>
+            </a:pPr>
+            <a:r>
+              <a:t>Defect ID</a:t>
+            </a:r>
+          </a:p>
+        </p:txBody>
+      </p:sp>
+      <p:sp>
+        <p:nvSpPr>
+          <p:cNvPr id="33" name="TextBox 32"/>
+          <p:cNvSpPr txBox="1"/>
+          <p:nvPr/>
+        </p:nvSpPr>
+        <p:spPr>
+          <a:xfrm>
+            <a:off x="4754880" y="3904488"/>
+            <a:ext cx="2743200" cy="274320"/>
+          </a:xfrm>
+          <a:prstGeom prst="rect">
+            <a:avLst/>
+          </a:prstGeom>
+          <a:noFill/>
+        </p:spPr>
+        <p:txBody>
+          <a:bodyPr wrap="square">
+            <a:spAutoFit/>
+          </a:bodyPr>
+          <a:lstStyle/>
+          <a:p>
+            <a:pPr algn="l">
+              <a:defRPr sz="1000" b="0">
+                <a:solidFill>
+                  <a:srgbClr val="FFFFFF"/>
+                </a:solidFill>
+                <a:latin typeface="Consolas"/>
+              </a:defRPr>
+            </a:pPr>
+            <a:r>
+              <a:t>hotfix/IS-890-patch-auth-bypass</a:t>
+            </a:r>
+          </a:p>
+        </p:txBody>
+      </p:sp>
+      <p:sp>
+        <p:nvSpPr>
+          <p:cNvPr id="34" name="Rounded Rectangle 33"/>
+          <p:cNvSpPr/>
+          <p:nvPr/>
+        </p:nvSpPr>
+        <p:spPr>
+          <a:xfrm>
+            <a:off x="1280160" y="4224528"/>
+            <a:ext cx="6126480" cy="329184"/>
+          </a:xfrm>
+          <a:prstGeom prst="roundRect">
+            <a:avLst/>
+          </a:prstGeom>
+          <a:solidFill>
+            <a:srgbClr val="26263E"/>
+          </a:solidFill>
+          <a:ln>
+            <a:noFill/>
+          </a:ln>
+          <a:effectLst/>
+        </p:spPr>
+        <p:style>
+          <a:lnRef idx="1">
+            <a:schemeClr val="accent1"/>
+          </a:lnRef>
+          <a:fillRef idx="3">
+            <a:schemeClr val="accent1"/>
+          </a:fillRef>
+          <a:effectRef idx="2">
+            <a:schemeClr val="accent1"/>
+          </a:effectRef>
+          <a:fontRef idx="minor">
+            <a:schemeClr val="lt1"/>
+          </a:fontRef>
+        </p:style>
+        <p:txBody>
+          <a:bodyPr rtlCol="0" anchor="ctr"/>
+          <a:lstStyle/>
+          <a:p>
+            <a:pPr algn="ctr"/>
+          </a:p>
+        </p:txBody>
+      </p:sp>
+      <p:sp>
+        <p:nvSpPr>
+          <p:cNvPr id="35" name="TextBox 34"/>
+          <p:cNvSpPr txBox="1"/>
+          <p:nvPr/>
+        </p:nvSpPr>
+        <p:spPr>
+          <a:xfrm>
+            <a:off x="1371600" y="4251960"/>
+            <a:ext cx="1188720" cy="274320"/>
+          </a:xfrm>
+          <a:prstGeom prst="rect">
+            <a:avLst/>
+          </a:prstGeom>
+          <a:noFill/>
+        </p:spPr>
+        <p:txBody>
+          <a:bodyPr wrap="square">
+            <a:spAutoFit/>
+          </a:bodyPr>
+          <a:lstStyle/>
+          <a:p>
+            <a:pPr algn="l">
+              <a:defRPr sz="1100" b="1">
+                <a:solidFill>
+                  <a:srgbClr val="888899"/>
+                </a:solidFill>
+                <a:latin typeface="Consolas"/>
+              </a:defRPr>
+            </a:pPr>
+            <a:r>
+              <a:t>chore/</a:t>
+            </a:r>
+          </a:p>
+        </p:txBody>
+      </p:sp>
+      <p:sp>
+        <p:nvSpPr>
+          <p:cNvPr id="36" name="TextBox 35"/>
+          <p:cNvSpPr txBox="1"/>
+          <p:nvPr/>
+        </p:nvSpPr>
+        <p:spPr>
+          <a:xfrm>
+            <a:off x="2560320" y="4251960"/>
+            <a:ext cx="914400" cy="274320"/>
+          </a:xfrm>
+          <a:prstGeom prst="rect">
+            <a:avLst/>
+          </a:prstGeom>
+          <a:noFill/>
+        </p:spPr>
+        <p:txBody>
+          <a:bodyPr wrap="square">
+            <a:spAutoFit/>
+          </a:bodyPr>
+          <a:lstStyle/>
+          <a:p>
+            <a:pPr algn="l">
+              <a:defRPr sz="1100" b="0">
+                <a:solidFill>
+                  <a:srgbClr val="FFFFFF"/>
+                </a:solidFill>
+                <a:latin typeface="Consolas"/>
+              </a:defRPr>
+            </a:pPr>
+            <a:r>
+              <a:t>IS-321</a:t>
+            </a:r>
+          </a:p>
+        </p:txBody>
+      </p:sp>
+      <p:sp>
+        <p:nvSpPr>
+          <p:cNvPr id="37" name="TextBox 36"/>
+          <p:cNvSpPr txBox="1"/>
+          <p:nvPr/>
+        </p:nvSpPr>
+        <p:spPr>
+          <a:xfrm>
+            <a:off x="3474720" y="4251960"/>
+            <a:ext cx="1097280" cy="274320"/>
+          </a:xfrm>
+          <a:prstGeom prst="rect">
+            <a:avLst/>
+          </a:prstGeom>
+          <a:noFill/>
+        </p:spPr>
+        <p:txBody>
+          <a:bodyPr wrap="square">
+            <a:spAutoFit/>
+          </a:bodyPr>
+          <a:lstStyle/>
+          <a:p>
+            <a:pPr algn="l">
+              <a:defRPr sz="1000" b="0">
+                <a:solidFill>
+                  <a:srgbClr val="BBBBCC"/>
+                </a:solidFill>
+                <a:latin typeface="Calibri"/>
+              </a:defRPr>
+            </a:pPr>
+            <a:r>
+              <a:t>Task ID</a:t>
+            </a:r>
+          </a:p>
+        </p:txBody>
+      </p:sp>
+      <p:sp>
+        <p:nvSpPr>
+          <p:cNvPr id="38" name="TextBox 37"/>
+          <p:cNvSpPr txBox="1"/>
+          <p:nvPr/>
+        </p:nvSpPr>
+        <p:spPr>
+          <a:xfrm>
+            <a:off x="4754880" y="4251960"/>
+            <a:ext cx="2743200" cy="274320"/>
+          </a:xfrm>
+          <a:prstGeom prst="rect">
+            <a:avLst/>
+          </a:prstGeom>
+          <a:noFill/>
+        </p:spPr>
+        <p:txBody>
+          <a:bodyPr wrap="square">
+            <a:spAutoFit/>
+          </a:bodyPr>
+          <a:lstStyle/>
+          <a:p>
+            <a:pPr algn="l">
+              <a:defRPr sz="1000" b="0">
+                <a:solidFill>
+                  <a:srgbClr val="FFFFFF"/>
+                </a:solidFill>
+                <a:latin typeface="Consolas"/>
+              </a:defRPr>
+            </a:pPr>
+            <a:r>
+              <a:t>chore/IS-321-upgrade-spring</a:t>
+            </a:r>
+          </a:p>
+        </p:txBody>
+      </p:sp>
+      <p:sp>
+        <p:nvSpPr>
+          <p:cNvPr id="39" name="TextBox 38"/>
+          <p:cNvSpPr txBox="1"/>
+          <p:nvPr/>
+        </p:nvSpPr>
+        <p:spPr>
+          <a:xfrm>
+            <a:off x="1371600" y="4599432"/>
+            <a:ext cx="1188720" cy="274320"/>
+          </a:xfrm>
+          <a:prstGeom prst="rect">
+            <a:avLst/>
+          </a:prstGeom>
+          <a:noFill/>
+        </p:spPr>
+        <p:txBody>
+          <a:bodyPr wrap="square">
+            <a:spAutoFit/>
+          </a:bodyPr>
+          <a:lstStyle/>
+          <a:p>
+            <a:pPr algn="l">
+              <a:defRPr sz="1100" b="1">
+                <a:solidFill>
+                  <a:srgbClr val="00C97B"/>
+                </a:solidFill>
+                <a:latin typeface="Consolas"/>
+              </a:defRPr>
+            </a:pPr>
+            <a:r>
+              <a:t>release/</a:t>
+            </a:r>
+          </a:p>
+        </p:txBody>
+      </p:sp>
+      <p:sp>
+        <p:nvSpPr>
+          <p:cNvPr id="40" name="TextBox 39"/>
+          <p:cNvSpPr txBox="1"/>
+          <p:nvPr/>
+        </p:nvSpPr>
+        <p:spPr>
+          <a:xfrm>
+            <a:off x="2560320" y="4599432"/>
+            <a:ext cx="914400" cy="274320"/>
+          </a:xfrm>
+          <a:prstGeom prst="rect">
+            <a:avLst/>
+          </a:prstGeom>
+          <a:noFill/>
+        </p:spPr>
+        <p:txBody>
+          <a:bodyPr wrap="square">
+            <a:spAutoFit/>
+          </a:bodyPr>
+          <a:lstStyle/>
+          <a:p>
+            <a:pPr algn="l">
+              <a:defRPr sz="1100" b="0">
+                <a:solidFill>
+                  <a:srgbClr val="FFFFFF"/>
+                </a:solidFill>
+                <a:latin typeface="Consolas"/>
+              </a:defRPr>
+            </a:pPr>
+            <a:r>
+              <a:t>vX.Y.Z</a:t>
+            </a:r>
+          </a:p>
+        </p:txBody>
+      </p:sp>
+      <p:sp>
+        <p:nvSpPr>
+          <p:cNvPr id="41" name="TextBox 40"/>
+          <p:cNvSpPr txBox="1"/>
+          <p:nvPr/>
+        </p:nvSpPr>
+        <p:spPr>
+          <a:xfrm>
+            <a:off x="3474720" y="4599432"/>
+            <a:ext cx="1097280" cy="274320"/>
+          </a:xfrm>
+          <a:prstGeom prst="rect">
+            <a:avLst/>
+          </a:prstGeom>
+          <a:noFill/>
+        </p:spPr>
+        <p:txBody>
+          <a:bodyPr wrap="square">
+            <a:spAutoFit/>
+          </a:bodyPr>
+          <a:lstStyle/>
+          <a:p>
+            <a:pPr algn="l">
+              <a:defRPr sz="1000" b="0">
+                <a:solidFill>
+                  <a:srgbClr val="BBBBCC"/>
+                </a:solidFill>
+                <a:latin typeface="Calibri"/>
+              </a:defRPr>
+            </a:pPr>
+            <a:r>
+              <a:t>Version</a:t>
+            </a:r>
+          </a:p>
+        </p:txBody>
+      </p:sp>
+      <p:sp>
+        <p:nvSpPr>
+          <p:cNvPr id="42" name="TextBox 41"/>
+          <p:cNvSpPr txBox="1"/>
+          <p:nvPr/>
+        </p:nvSpPr>
+        <p:spPr>
+          <a:xfrm>
+            <a:off x="4754880" y="4599432"/>
+            <a:ext cx="2743200" cy="274320"/>
+          </a:xfrm>
+          <a:prstGeom prst="rect">
+            <a:avLst/>
+          </a:prstGeom>
+          <a:noFill/>
+        </p:spPr>
+        <p:txBody>
+          <a:bodyPr wrap="square">
+            <a:spAutoFit/>
+          </a:bodyPr>
+          <a:lstStyle/>
+          <a:p>
+            <a:pPr algn="l">
+              <a:defRPr sz="1000" b="0">
+                <a:solidFill>
+                  <a:srgbClr val="FFFFFF"/>
+                </a:solidFill>
+                <a:latin typeface="Consolas"/>
+              </a:defRPr>
+            </a:pPr>
+            <a:r>
+              <a:t>release/v2.4.0</a:t>
+            </a:r>
+          </a:p>
+        </p:txBody>
+      </p:sp>
+      <p:sp>
+        <p:nvSpPr>
+          <p:cNvPr id="43" name="Rounded Rectangle 42"/>
+          <p:cNvSpPr/>
+          <p:nvPr/>
+        </p:nvSpPr>
+        <p:spPr>
+          <a:xfrm>
+            <a:off x="1097280" y="4754880"/>
+            <a:ext cx="411480" cy="411480"/>
+          </a:xfrm>
+          <a:prstGeom prst="roundRect">
+            <a:avLst/>
+          </a:prstGeom>
+          <a:solidFill>
+            <a:srgbClr val="00C97B"/>
+          </a:solidFill>
+          <a:ln>
+            <a:noFill/>
+          </a:ln>
+          <a:effectLst/>
+        </p:spPr>
+        <p:style>
+          <a:lnRef idx="1">
+            <a:schemeClr val="accent1"/>
+          </a:lnRef>
+          <a:fillRef idx="3">
+            <a:schemeClr val="accent1"/>
+          </a:fillRef>
+          <a:effectRef idx="2">
+            <a:schemeClr val="accent1"/>
+          </a:effectRef>
+          <a:fontRef idx="minor">
+            <a:schemeClr val="lt1"/>
+          </a:fontRef>
+        </p:style>
+        <p:txBody>
+          <a:bodyPr rtlCol="0" anchor="ctr"/>
+          <a:lstStyle/>
+          <a:p>
+            <a:pPr algn="ctr"/>
+          </a:p>
+        </p:txBody>
+      </p:sp>
+      <p:sp>
+        <p:nvSpPr>
+          <p:cNvPr id="44" name="TextBox 43"/>
+          <p:cNvSpPr txBox="1"/>
+          <p:nvPr/>
+        </p:nvSpPr>
+        <p:spPr>
+          <a:xfrm>
+            <a:off x="1097280" y="4773168"/>
+            <a:ext cx="411480" cy="365760"/>
+          </a:xfrm>
+          <a:prstGeom prst="rect">
+            <a:avLst/>
+          </a:prstGeom>
+          <a:noFill/>
+        </p:spPr>
+        <p:txBody>
+          <a:bodyPr wrap="square">
+            <a:spAutoFit/>
+          </a:bodyPr>
+          <a:lstStyle/>
+          <a:p>
+            <a:pPr algn="ctr">
+              <a:defRPr sz="1800" b="1">
+                <a:solidFill>
+                  <a:srgbClr val="FFFFFF"/>
+                </a:solidFill>
+                <a:latin typeface="Calibri"/>
+              </a:defRPr>
+            </a:pPr>
+            <a:r>
+              <a:t>2</a:t>
+            </a:r>
+          </a:p>
+        </p:txBody>
+      </p:sp>
+      <p:sp>
+        <p:nvSpPr>
+          <p:cNvPr id="45" name="TextBox 44"/>
+          <p:cNvSpPr txBox="1"/>
+          <p:nvPr/>
+        </p:nvSpPr>
+        <p:spPr>
+          <a:xfrm>
+            <a:off x="1645920" y="4754880"/>
+            <a:ext cx="5669280" cy="411480"/>
+          </a:xfrm>
+          <a:prstGeom prst="rect">
+            <a:avLst/>
+          </a:prstGeom>
+          <a:noFill/>
+        </p:spPr>
+        <p:txBody>
+          <a:bodyPr wrap="square">
+            <a:spAutoFit/>
+          </a:bodyPr>
+          <a:lstStyle/>
+          <a:p>
+            <a:pPr algn="l">
+              <a:defRPr sz="1600" b="1">
+                <a:solidFill>
+                  <a:srgbClr val="FFFFFF"/>
+                </a:solidFill>
+                <a:latin typeface="Calibri"/>
+              </a:defRPr>
+            </a:pPr>
+            <a:r>
+              <a:t>Include the ticket ID in your PR title</a:t>
+            </a:r>
+          </a:p>
+        </p:txBody>
+      </p:sp>
+      <p:sp>
+        <p:nvSpPr>
+          <p:cNvPr id="46" name="Rectangle 45"/>
+          <p:cNvSpPr/>
+          <p:nvPr/>
+        </p:nvSpPr>
+        <p:spPr>
+          <a:xfrm>
+            <a:off x="1371600" y="5303520"/>
+            <a:ext cx="54864" cy="228600"/>
+          </a:xfrm>
+          <a:prstGeom prst="rect">
+            <a:avLst/>
+          </a:prstGeom>
+          <a:solidFill>
+            <a:srgbClr val="008CFF"/>
+          </a:solidFill>
+          <a:ln>
+            <a:noFill/>
+          </a:ln>
+        </p:spPr>
+        <p:style>
+          <a:lnRef idx="1">
+            <a:schemeClr val="accent1"/>
+          </a:lnRef>
+          <a:fillRef idx="3">
+            <a:schemeClr val="accent1"/>
+          </a:fillRef>
+          <a:effectRef idx="2">
+            <a:schemeClr val="accent1"/>
+          </a:effectRef>
+          <a:fontRef idx="minor">
+            <a:schemeClr val="lt1"/>
+          </a:fontRef>
+        </p:style>
+        <p:txBody>
+          <a:bodyPr rtlCol="0" anchor="ctr"/>
+          <a:lstStyle/>
+          <a:p>
+            <a:pPr algn="ctr"/>
+          </a:p>
+        </p:txBody>
+      </p:sp>
+      <p:sp>
+        <p:nvSpPr>
+          <p:cNvPr id="47" name="TextBox 46"/>
+          <p:cNvSpPr txBox="1"/>
+          <p:nvPr/>
+        </p:nvSpPr>
+        <p:spPr>
+          <a:xfrm>
+            <a:off x="1645920" y="5257800"/>
+            <a:ext cx="5669280" cy="320040"/>
+          </a:xfrm>
+          <a:prstGeom prst="rect">
+            <a:avLst/>
+          </a:prstGeom>
+          <a:noFill/>
+        </p:spPr>
+        <p:txBody>
+          <a:bodyPr wrap="square">
+            <a:spAutoFit/>
+          </a:bodyPr>
+          <a:lstStyle/>
+          <a:p>
+            <a:pPr algn="l">
+              <a:defRPr sz="1200" b="0">
+                <a:solidFill>
+                  <a:srgbClr val="FFFFFF"/>
+                </a:solidFill>
+                <a:latin typeface="Consolas"/>
+              </a:defRPr>
+            </a:pPr>
+            <a:r>
+              <a:t>feat(auth): IS-1234 Add OAuth login flow</a:t>
+            </a:r>
+          </a:p>
+        </p:txBody>
+      </p:sp>
+      <p:sp>
+        <p:nvSpPr>
+          <p:cNvPr id="48" name="Rectangle 47"/>
+          <p:cNvSpPr/>
+          <p:nvPr/>
+        </p:nvSpPr>
+        <p:spPr>
+          <a:xfrm>
+            <a:off x="1371600" y="5669280"/>
+            <a:ext cx="54864" cy="228600"/>
+          </a:xfrm>
+          <a:prstGeom prst="rect">
+            <a:avLst/>
+          </a:prstGeom>
+          <a:solidFill>
+            <a:srgbClr val="FF8C00"/>
+          </a:solidFill>
+          <a:ln>
+            <a:noFill/>
+          </a:ln>
+        </p:spPr>
+        <p:style>
+          <a:lnRef idx="1">
+            <a:schemeClr val="accent1"/>
+          </a:lnRef>
+          <a:fillRef idx="3">
+            <a:schemeClr val="accent1"/>
+          </a:fillRef>
+          <a:effectRef idx="2">
+            <a:schemeClr val="accent1"/>
+          </a:effectRef>
+          <a:fontRef idx="minor">
+            <a:schemeClr val="lt1"/>
+          </a:fontRef>
+        </p:style>
+        <p:txBody>
+          <a:bodyPr rtlCol="0" anchor="ctr"/>
+          <a:lstStyle/>
+          <a:p>
+            <a:pPr algn="ctr"/>
+          </a:p>
+        </p:txBody>
+      </p:sp>
+      <p:sp>
+        <p:nvSpPr>
+          <p:cNvPr id="49" name="TextBox 48"/>
+          <p:cNvSpPr txBox="1"/>
+          <p:nvPr/>
+        </p:nvSpPr>
+        <p:spPr>
+          <a:xfrm>
+            <a:off x="1645920" y="5623560"/>
+            <a:ext cx="5669280" cy="320040"/>
+          </a:xfrm>
+          <a:prstGeom prst="rect">
+            <a:avLst/>
+          </a:prstGeom>
+          <a:noFill/>
+        </p:spPr>
+        <p:txBody>
+          <a:bodyPr wrap="square">
+            <a:spAutoFit/>
+          </a:bodyPr>
+          <a:lstStyle/>
+          <a:p>
+            <a:pPr algn="l">
+              <a:defRPr sz="1200" b="0">
+                <a:solidFill>
+                  <a:srgbClr val="FFFFFF"/>
+                </a:solidFill>
+                <a:latin typeface="Consolas"/>
+              </a:defRPr>
+            </a:pPr>
+            <a:r>
+              <a:t>fix(api): IS-567 Resolve timeout on bulk export</a:t>
+            </a:r>
+          </a:p>
+        </p:txBody>
+      </p:sp>
+      <p:sp>
+        <p:nvSpPr>
+          <p:cNvPr id="50" name="Rectangle 49"/>
+          <p:cNvSpPr/>
+          <p:nvPr/>
+        </p:nvSpPr>
+        <p:spPr>
+          <a:xfrm>
+            <a:off x="1371600" y="6035040"/>
+            <a:ext cx="54864" cy="228600"/>
+          </a:xfrm>
+          <a:prstGeom prst="rect">
+            <a:avLst/>
+          </a:prstGeom>
+          <a:solidFill>
+            <a:srgbClr val="FF4545"/>
+          </a:solidFill>
+          <a:ln>
+            <a:noFill/>
+          </a:ln>
+        </p:spPr>
+        <p:style>
+          <a:lnRef idx="1">
+            <a:schemeClr val="accent1"/>
+          </a:lnRef>
+          <a:fillRef idx="3">
+            <a:schemeClr val="accent1"/>
+          </a:fillRef>
+          <a:effectRef idx="2">
+            <a:schemeClr val="accent1"/>
+          </a:effectRef>
+          <a:fontRef idx="minor">
+            <a:schemeClr val="lt1"/>
+          </a:fontRef>
+        </p:style>
+        <p:txBody>
+          <a:bodyPr rtlCol="0" anchor="ctr"/>
+          <a:lstStyle/>
+          <a:p>
+            <a:pPr algn="ctr"/>
+          </a:p>
+        </p:txBody>
+      </p:sp>
+      <p:sp>
+        <p:nvSpPr>
+          <p:cNvPr id="51" name="TextBox 50"/>
+          <p:cNvSpPr txBox="1"/>
+          <p:nvPr/>
+        </p:nvSpPr>
+        <p:spPr>
+          <a:xfrm>
+            <a:off x="1645920" y="5989320"/>
+            <a:ext cx="5669280" cy="320040"/>
+          </a:xfrm>
+          <a:prstGeom prst="rect">
+            <a:avLst/>
+          </a:prstGeom>
+          <a:noFill/>
+        </p:spPr>
+        <p:txBody>
+          <a:bodyPr wrap="square">
+            <a:spAutoFit/>
+          </a:bodyPr>
+          <a:lstStyle/>
+          <a:p>
+            <a:pPr algn="l">
+              <a:defRPr sz="1200" b="0">
+                <a:solidFill>
+                  <a:srgbClr val="FFFFFF"/>
+                </a:solidFill>
+                <a:latin typeface="Consolas"/>
+              </a:defRPr>
+            </a:pPr>
+            <a:r>
+              <a:t>hotfix(payments): IS-890 Patch null pointer</a:t>
+            </a:r>
+          </a:p>
+        </p:txBody>
+      </p:sp>
+      <p:sp>
+        <p:nvSpPr>
+          <p:cNvPr id="52" name="Rounded Rectangle 51"/>
+          <p:cNvSpPr/>
+          <p:nvPr/>
+        </p:nvSpPr>
+        <p:spPr>
+          <a:xfrm>
+            <a:off x="8046720" y="1371600"/>
+            <a:ext cx="3383280" cy="5212080"/>
+          </a:xfrm>
+          <a:prstGeom prst="roundRect">
+            <a:avLst/>
+          </a:prstGeom>
+          <a:solidFill>
+            <a:srgbClr val="26263E"/>
+          </a:solidFill>
+          <a:ln>
+            <a:noFill/>
+          </a:ln>
+          <a:effectLst/>
+        </p:spPr>
+        <p:style>
+          <a:lnRef idx="1">
+            <a:schemeClr val="accent1"/>
+          </a:lnRef>
+          <a:fillRef idx="3">
+            <a:schemeClr val="accent1"/>
+          </a:fillRef>
+          <a:effectRef idx="2">
+            <a:schemeClr val="accent1"/>
+          </a:effectRef>
+          <a:fontRef idx="minor">
+            <a:schemeClr val="lt1"/>
+          </a:fontRef>
+        </p:style>
+        <p:txBody>
+          <a:bodyPr rtlCol="0" anchor="ctr"/>
+          <a:lstStyle/>
+          <a:p>
+            <a:pPr algn="ctr"/>
+          </a:p>
+        </p:txBody>
+      </p:sp>
+      <p:sp>
+        <p:nvSpPr>
+          <p:cNvPr id="53" name="Rectangle 52"/>
+          <p:cNvSpPr/>
+          <p:nvPr/>
+        </p:nvSpPr>
+        <p:spPr>
+          <a:xfrm>
+            <a:off x="8046720" y="1371600"/>
+            <a:ext cx="73152" cy="5212080"/>
+          </a:xfrm>
+          <a:prstGeom prst="rect">
+            <a:avLst/>
+          </a:prstGeom>
+          <a:solidFill>
+            <a:srgbClr val="A85CFF"/>
+          </a:solidFill>
+          <a:ln>
+            <a:noFill/>
+          </a:ln>
+        </p:spPr>
+        <p:style>
+          <a:lnRef idx="1">
+            <a:schemeClr val="accent1"/>
+          </a:lnRef>
+          <a:fillRef idx="3">
+            <a:schemeClr val="accent1"/>
+          </a:fillRef>
+          <a:effectRef idx="2">
+            <a:schemeClr val="accent1"/>
+          </a:effectRef>
+          <a:fontRef idx="minor">
+            <a:schemeClr val="lt1"/>
+          </a:fontRef>
+        </p:style>
+        <p:txBody>
+          <a:bodyPr rtlCol="0" anchor="ctr"/>
+          <a:lstStyle/>
+          <a:p>
+            <a:pPr algn="ctr"/>
+          </a:p>
+        </p:txBody>
+      </p:sp>
+      <p:sp>
+        <p:nvSpPr>
+          <p:cNvPr id="54" name="TextBox 53"/>
+          <p:cNvSpPr txBox="1"/>
+          <p:nvPr/>
+        </p:nvSpPr>
+        <p:spPr>
+          <a:xfrm>
+            <a:off x="8321040" y="1463040"/>
+            <a:ext cx="2926080" cy="365760"/>
+          </a:xfrm>
+          <a:prstGeom prst="rect">
+            <a:avLst/>
+          </a:prstGeom>
+          <a:noFill/>
+        </p:spPr>
+        <p:txBody>
+          <a:bodyPr wrap="square">
+            <a:spAutoFit/>
+          </a:bodyPr>
+          <a:lstStyle/>
+          <a:p>
+            <a:pPr algn="l">
+              <a:defRPr sz="1400" b="1">
+                <a:solidFill>
+                  <a:srgbClr val="A85CFF"/>
+                </a:solidFill>
+                <a:latin typeface="Calibri"/>
+              </a:defRPr>
+            </a:pPr>
+            <a:r>
+              <a:t>AUTOMATION HANDLES</a:t>
+            </a:r>
+          </a:p>
+        </p:txBody>
+      </p:sp>
+      <p:sp>
+        <p:nvSpPr>
+          <p:cNvPr id="55" name="TextBox 54"/>
+          <p:cNvSpPr txBox="1"/>
+          <p:nvPr/>
+        </p:nvSpPr>
+        <p:spPr>
+          <a:xfrm>
+            <a:off x="8321040" y="1965960"/>
+            <a:ext cx="2926080" cy="274320"/>
+          </a:xfrm>
+          <a:prstGeom prst="rect">
+            <a:avLst/>
+          </a:prstGeom>
+          <a:noFill/>
+        </p:spPr>
+        <p:txBody>
+          <a:bodyPr wrap="square">
+            <a:spAutoFit/>
+          </a:bodyPr>
+          <a:lstStyle/>
+          <a:p>
+            <a:pPr algn="l">
+              <a:defRPr sz="1200" b="1">
+                <a:solidFill>
+                  <a:srgbClr val="A85CFF"/>
+                </a:solidFill>
+                <a:latin typeface="Calibri"/>
+              </a:defRPr>
+            </a:pPr>
+            <a:r>
+              <a:t>Commit messages</a:t>
+            </a:r>
+          </a:p>
+        </p:txBody>
+      </p:sp>
+      <p:sp>
+        <p:nvSpPr>
+          <p:cNvPr id="56" name="TextBox 55"/>
+          <p:cNvSpPr txBox="1"/>
+          <p:nvPr/>
+        </p:nvSpPr>
+        <p:spPr>
+          <a:xfrm>
+            <a:off x="8321040" y="2240280"/>
+            <a:ext cx="2926080" cy="777240"/>
+          </a:xfrm>
+          <a:prstGeom prst="rect">
+            <a:avLst/>
+          </a:prstGeom>
+          <a:noFill/>
+        </p:spPr>
+        <p:txBody>
+          <a:bodyPr wrap="square">
+            <a:spAutoFit/>
+          </a:bodyPr>
+          <a:lstStyle/>
+          <a:p>
+            <a:pPr algn="l">
+              <a:defRPr sz="1000" b="0">
+                <a:solidFill>
+                  <a:srgbClr val="BBBBCC"/>
+                </a:solidFill>
+                <a:latin typeface="Calibri"/>
+              </a:defRPr>
+            </a:pPr>
+            <a:r>
+              <a:t>prepare-commit-msg hook</a:t>
+            </a:r>
+            <a:br/>
+            <a:r>
+              <a:t>extracts ticket ID from</a:t>
+            </a:r>
+            <a:br/>
+            <a:r>
+              <a:t>branch name and appends</a:t>
+            </a:r>
+            <a:br/>
+            <a:r>
+              <a:t>Refs: IS-1234 to every</a:t>
+            </a:r>
+            <a:br/>
+            <a:r>
+              <a:t>commit automatically.</a:t>
+            </a:r>
+          </a:p>
+        </p:txBody>
+      </p:sp>
+      <p:sp>
+        <p:nvSpPr>
+          <p:cNvPr id="57" name="TextBox 56"/>
+          <p:cNvSpPr txBox="1"/>
+          <p:nvPr/>
+        </p:nvSpPr>
+        <p:spPr>
+          <a:xfrm>
+            <a:off x="8321040" y="3063240"/>
+            <a:ext cx="2926080" cy="274320"/>
+          </a:xfrm>
+          <a:prstGeom prst="rect">
+            <a:avLst/>
+          </a:prstGeom>
+          <a:noFill/>
+        </p:spPr>
+        <p:txBody>
+          <a:bodyPr wrap="square">
+            <a:spAutoFit/>
+          </a:bodyPr>
+          <a:lstStyle/>
+          <a:p>
+            <a:pPr algn="l">
+              <a:defRPr sz="1200" b="1">
+                <a:solidFill>
+                  <a:srgbClr val="008CFF"/>
+                </a:solidFill>
+                <a:latin typeface="Calibri"/>
+              </a:defRPr>
+            </a:pPr>
+            <a:r>
+              <a:t>Branch name validation</a:t>
+            </a:r>
+          </a:p>
+        </p:txBody>
+      </p:sp>
+      <p:sp>
+        <p:nvSpPr>
+          <p:cNvPr id="58" name="TextBox 57"/>
+          <p:cNvSpPr txBox="1"/>
+          <p:nvPr/>
+        </p:nvSpPr>
+        <p:spPr>
+          <a:xfrm>
+            <a:off x="8321040" y="3337560"/>
+            <a:ext cx="2926080" cy="777240"/>
+          </a:xfrm>
+          <a:prstGeom prst="rect">
+            <a:avLst/>
+          </a:prstGeom>
+          <a:noFill/>
+        </p:spPr>
+        <p:txBody>
+          <a:bodyPr wrap="square">
+            <a:spAutoFit/>
+          </a:bodyPr>
+          <a:lstStyle/>
+          <a:p>
+            <a:pPr algn="l">
+              <a:defRPr sz="1000" b="0">
+                <a:solidFill>
+                  <a:srgbClr val="BBBBCC"/>
+                </a:solidFill>
+                <a:latin typeface="Calibri"/>
+              </a:defRPr>
+            </a:pPr>
+            <a:r>
+              <a:t>CI rejects PRs from</a:t>
+            </a:r>
+            <a:br/>
+            <a:r>
+              <a:t>branches that don't match</a:t>
+            </a:r>
+            <a:br/>
+            <a:r>
+              <a:t>the naming pattern.</a:t>
+            </a:r>
+          </a:p>
+        </p:txBody>
+      </p:sp>
+      <p:sp>
+        <p:nvSpPr>
+          <p:cNvPr id="59" name="TextBox 58"/>
+          <p:cNvSpPr txBox="1"/>
+          <p:nvPr/>
+        </p:nvSpPr>
+        <p:spPr>
+          <a:xfrm>
+            <a:off x="8321040" y="4160520"/>
+            <a:ext cx="2926080" cy="274320"/>
+          </a:xfrm>
+          <a:prstGeom prst="rect">
+            <a:avLst/>
+          </a:prstGeom>
+          <a:noFill/>
+        </p:spPr>
+        <p:txBody>
+          <a:bodyPr wrap="square">
+            <a:spAutoFit/>
+          </a:bodyPr>
+          <a:lstStyle/>
+          <a:p>
+            <a:pPr algn="l">
+              <a:defRPr sz="1200" b="1">
+                <a:solidFill>
+                  <a:srgbClr val="FF8C00"/>
+                </a:solidFill>
+                <a:latin typeface="Calibri"/>
+              </a:defRPr>
+            </a:pPr>
+            <a:r>
+              <a:t>PR title validation</a:t>
+            </a:r>
+          </a:p>
+        </p:txBody>
+      </p:sp>
+      <p:sp>
+        <p:nvSpPr>
+          <p:cNvPr id="60" name="TextBox 59"/>
+          <p:cNvSpPr txBox="1"/>
+          <p:nvPr/>
+        </p:nvSpPr>
+        <p:spPr>
+          <a:xfrm>
+            <a:off x="8321040" y="4434840"/>
+            <a:ext cx="2926080" cy="777240"/>
+          </a:xfrm>
+          <a:prstGeom prst="rect">
+            <a:avLst/>
+          </a:prstGeom>
+          <a:noFill/>
+        </p:spPr>
+        <p:txBody>
+          <a:bodyPr wrap="square">
+            <a:spAutoFit/>
+          </a:bodyPr>
+          <a:lstStyle/>
+          <a:p>
+            <a:pPr algn="l">
+              <a:defRPr sz="1000" b="0">
+                <a:solidFill>
+                  <a:srgbClr val="BBBBCC"/>
+                </a:solidFill>
+                <a:latin typeface="Calibri"/>
+              </a:defRPr>
+            </a:pPr>
+            <a:r>
+              <a:t>CI checks that PR title</a:t>
+            </a:r>
+            <a:br/>
+            <a:r>
+              <a:t>follows conventional</a:t>
+            </a:r>
+            <a:br/>
+            <a:r>
+              <a:t>format with ticket ID.</a:t>
+            </a:r>
+          </a:p>
+        </p:txBody>
+      </p:sp>
+      <p:sp>
+        <p:nvSpPr>
+          <p:cNvPr id="61" name="TextBox 60"/>
+          <p:cNvSpPr txBox="1"/>
+          <p:nvPr/>
+        </p:nvSpPr>
+        <p:spPr>
+          <a:xfrm>
+            <a:off x="8321040" y="5257800"/>
+            <a:ext cx="2926080" cy="274320"/>
+          </a:xfrm>
+          <a:prstGeom prst="rect">
+            <a:avLst/>
+          </a:prstGeom>
+          <a:noFill/>
+        </p:spPr>
+        <p:txBody>
+          <a:bodyPr wrap="square">
+            <a:spAutoFit/>
+          </a:bodyPr>
+          <a:lstStyle/>
+          <a:p>
+            <a:pPr algn="l">
+              <a:defRPr sz="1200" b="1">
+                <a:solidFill>
+                  <a:srgbClr val="00C97B"/>
+                </a:solidFill>
+                <a:latin typeface="Calibri"/>
+              </a:defRPr>
+            </a:pPr>
+            <a:r>
+              <a:t>Merge commit tagging</a:t>
+            </a:r>
+          </a:p>
+        </p:txBody>
+      </p:sp>
+      <p:sp>
+        <p:nvSpPr>
+          <p:cNvPr id="62" name="TextBox 61"/>
+          <p:cNvSpPr txBox="1"/>
+          <p:nvPr/>
+        </p:nvSpPr>
+        <p:spPr>
+          <a:xfrm>
+            <a:off x="8321040" y="5532120"/>
+            <a:ext cx="2926080" cy="777240"/>
+          </a:xfrm>
+          <a:prstGeom prst="rect">
+            <a:avLst/>
+          </a:prstGeom>
+          <a:noFill/>
+        </p:spPr>
+        <p:txBody>
+          <a:bodyPr wrap="square">
+            <a:spAutoFit/>
+          </a:bodyPr>
+          <a:lstStyle/>
+          <a:p>
+            <a:pPr algn="l">
+              <a:defRPr sz="1000" b="0">
+                <a:solidFill>
+                  <a:srgbClr val="BBBBCC"/>
+                </a:solidFill>
+                <a:latin typeface="Calibri"/>
+              </a:defRPr>
+            </a:pPr>
+            <a:r>
+              <a:t>Squash-merge commit</a:t>
+            </a:r>
+            <a:br/>
+            <a:r>
+              <a:t>automatically includes</a:t>
+            </a:r>
+            <a:br/>
+            <a:r>
+              <a:t>PR number and ticket ID.</a:t>
+            </a:r>
+          </a:p>
+        </p:txBody>
+      </p:sp>
+      <p:sp>
+        <p:nvSpPr>
+          <p:cNvPr id="63" name="Rounded Rectangle 62"/>
+          <p:cNvSpPr/>
+          <p:nvPr/>
+        </p:nvSpPr>
+        <p:spPr>
+          <a:xfrm>
+            <a:off x="731520" y="6720840"/>
+            <a:ext cx="10515600" cy="0"/>
+          </a:xfrm>
+          <a:prstGeom prst="roundRect">
+            <a:avLst/>
+          </a:prstGeom>
+          <a:solidFill>
+            <a:srgbClr val="26263E"/>
+          </a:solidFill>
+          <a:ln>
+            <a:noFill/>
+          </a:ln>
+          <a:effectLst/>
+        </p:spPr>
+        <p:style>
+          <a:lnRef idx="1">
+            <a:schemeClr val="accent1"/>
+          </a:lnRef>
+          <a:fillRef idx="3">
+            <a:schemeClr val="accent1"/>
+          </a:fillRef>
+          <a:effectRef idx="2">
+            <a:schemeClr val="accent1"/>
+          </a:effectRef>
+          <a:fontRef idx="minor">
+            <a:schemeClr val="lt1"/>
+          </a:fontRef>
+        </p:style>
+        <p:txBody>
+          <a:bodyPr rtlCol="0" anchor="ctr"/>
+          <a:lstStyle/>
+          <a:p>
+            <a:pPr algn="ctr"/>
+          </a:p>
+        </p:txBody>
+      </p:sp>
+      <p:sp>
+        <p:nvSpPr>
+          <p:cNvPr id="64" name="TextBox 63"/>
+          <p:cNvSpPr txBox="1"/>
+          <p:nvPr/>
+        </p:nvSpPr>
+        <p:spPr>
+          <a:xfrm>
+            <a:off x="11155680" y="6400800"/>
+            <a:ext cx="914400" cy="365760"/>
+          </a:xfrm>
+          <a:prstGeom prst="rect">
+            <a:avLst/>
+          </a:prstGeom>
+          <a:noFill/>
+        </p:spPr>
+        <p:txBody>
+          <a:bodyPr wrap="square">
+            <a:spAutoFit/>
+          </a:bodyPr>
+          <a:lstStyle/>
+          <a:p>
+            <a:pPr algn="r">
+              <a:defRPr sz="1100" b="0">
+                <a:solidFill>
+                  <a:srgbClr val="888899"/>
+                </a:solidFill>
+                <a:latin typeface="Calibri"/>
+              </a:defRPr>
+            </a:pPr>
+            <a:r>
+              <a:t>16 / 17</a:t>
+            </a:r>
+          </a:p>
+        </p:txBody>
+      </p:sp>
+    </p:spTree>
+  </p:cSld>
+  <p:clrMapOvr>
+    <a:masterClrMapping/>
+  </p:clrMapOvr>
+</p:sld>
+</file>
+
+<file path=ppt/slides/slide17.xml><?xml version="1.0" encoding="utf-8"?>
+<p:sld xmlns:a="http://schemas.openxmlformats.org/drawingml/2006/main" xmlns:p="http://schemas.openxmlformats.org/presentationml/2006/main" xmlns:r="http://schemas.openxmlformats.org/officeDocument/2006/relationships">
+  <p:cSld>
+    <p:bg>
+      <p:bgPr>
+        <a:solidFill>
+          <a:srgbClr val="1B1B2F"/>
+        </a:solidFill>
+        <a:effectLst/>
+      </p:bgPr>
+    </p:bg>
+    <p:spTree>
+      <p:nvGrpSpPr>
+        <p:cNvPr id="1" name=""/>
+        <p:cNvGrpSpPr/>
+        <p:nvPr/>
+      </p:nvGrpSpPr>
+      <p:grpSpPr/>
+      <p:sp>
+        <p:nvSpPr>
+          <p:cNvPr id="2" name="Rectangle 1"/>
+          <p:cNvSpPr/>
+          <p:nvPr/>
+        </p:nvSpPr>
+        <p:spPr>
+          <a:xfrm>
+            <a:off x="0" y="0"/>
+            <a:ext cx="12191695" cy="54864"/>
+          </a:xfrm>
+          <a:prstGeom prst="rect">
+            <a:avLst/>
+          </a:prstGeom>
+          <a:solidFill>
+            <a:srgbClr val="FF4545"/>
+          </a:solidFill>
+          <a:ln>
+            <a:noFill/>
+          </a:ln>
+        </p:spPr>
+        <p:style>
+          <a:lnRef idx="1">
+            <a:schemeClr val="accent1"/>
+          </a:lnRef>
+          <a:fillRef idx="3">
+            <a:schemeClr val="accent1"/>
+          </a:fillRef>
+          <a:effectRef idx="2">
+            <a:schemeClr val="accent1"/>
+          </a:effectRef>
+          <a:fontRef idx="minor">
+            <a:schemeClr val="lt1"/>
+          </a:fontRef>
+        </p:style>
+        <p:txBody>
+          <a:bodyPr rtlCol="0" anchor="ctr"/>
+          <a:lstStyle/>
+          <a:p>
+            <a:pPr algn="ctr"/>
+          </a:p>
+        </p:txBody>
+      </p:sp>
+      <p:sp>
+        <p:nvSpPr>
+          <p:cNvPr id="3" name="TextBox 2"/>
+          <p:cNvSpPr txBox="1"/>
+          <p:nvPr/>
+        </p:nvSpPr>
+        <p:spPr>
+          <a:xfrm>
+            <a:off x="731520" y="365760"/>
+            <a:ext cx="9144000" cy="640080"/>
+          </a:xfrm>
+          <a:prstGeom prst="rect">
+            <a:avLst/>
+          </a:prstGeom>
+          <a:noFill/>
+        </p:spPr>
+        <p:txBody>
+          <a:bodyPr wrap="square">
+            <a:spAutoFit/>
+          </a:bodyPr>
+          <a:lstStyle/>
+          <a:p>
+            <a:pPr algn="l">
+              <a:defRPr sz="3200" b="1">
+                <a:solidFill>
+                  <a:srgbClr val="FFFFFF"/>
+                </a:solidFill>
+                <a:latin typeface="Calibri"/>
+              </a:defRPr>
+            </a:pPr>
+            <a:r>
+              <a:t>Open Issue: Feature Branch Traceability Gap</a:t>
+            </a:r>
+          </a:p>
+        </p:txBody>
+      </p:sp>
+      <p:sp>
+        <p:nvSpPr>
+          <p:cNvPr id="4" name="TextBox 3"/>
+          <p:cNvSpPr txBox="1"/>
+          <p:nvPr/>
+        </p:nvSpPr>
+        <p:spPr>
+          <a:xfrm>
+            <a:off x="731520" y="914400"/>
+            <a:ext cx="9144000" cy="457200"/>
+          </a:xfrm>
+          <a:prstGeom prst="rect">
+            <a:avLst/>
+          </a:prstGeom>
+          <a:noFill/>
+        </p:spPr>
+        <p:txBody>
+          <a:bodyPr wrap="square">
+            <a:spAutoFit/>
+          </a:bodyPr>
+          <a:lstStyle/>
+          <a:p>
+            <a:pPr algn="l">
+              <a:defRPr sz="1400" b="0">
+                <a:solidFill>
+                  <a:srgbClr val="FF4545"/>
+                </a:solidFill>
+                <a:latin typeface="Calibri"/>
+              </a:defRPr>
+            </a:pPr>
+            <a:r>
+              <a:t>Feature branches can be created and deleted within minutes — losing all traceability of work done against a user story</a:t>
+            </a:r>
+          </a:p>
+        </p:txBody>
+      </p:sp>
+      <p:sp>
+        <p:nvSpPr>
+          <p:cNvPr id="5" name="Rounded Rectangle 4"/>
+          <p:cNvSpPr/>
+          <p:nvPr/>
+        </p:nvSpPr>
+        <p:spPr>
+          <a:xfrm>
+            <a:off x="731520" y="1371600"/>
+            <a:ext cx="10515600" cy="2377440"/>
+          </a:xfrm>
+          <a:prstGeom prst="roundRect">
+            <a:avLst/>
+          </a:prstGeom>
+          <a:solidFill>
+            <a:srgbClr val="26263E"/>
+          </a:solidFill>
+          <a:ln>
+            <a:noFill/>
+          </a:ln>
+          <a:effectLst/>
+        </p:spPr>
+        <p:style>
+          <a:lnRef idx="1">
+            <a:schemeClr val="accent1"/>
+          </a:lnRef>
+          <a:fillRef idx="3">
+            <a:schemeClr val="accent1"/>
+          </a:fillRef>
+          <a:effectRef idx="2">
+            <a:schemeClr val="accent1"/>
+          </a:effectRef>
+          <a:fontRef idx="minor">
+            <a:schemeClr val="lt1"/>
+          </a:fontRef>
+        </p:style>
+        <p:txBody>
+          <a:bodyPr rtlCol="0" anchor="ctr"/>
+          <a:lstStyle/>
+          <a:p>
+            <a:pPr algn="ctr"/>
+          </a:p>
+        </p:txBody>
+      </p:sp>
+      <p:sp>
+        <p:nvSpPr>
+          <p:cNvPr id="6" name="Rectangle 5"/>
+          <p:cNvSpPr/>
+          <p:nvPr/>
+        </p:nvSpPr>
+        <p:spPr>
+          <a:xfrm>
+            <a:off x="731520" y="1371600"/>
+            <a:ext cx="10515600" cy="54864"/>
+          </a:xfrm>
+          <a:prstGeom prst="rect">
+            <a:avLst/>
+          </a:prstGeom>
+          <a:solidFill>
+            <a:srgbClr val="FF4545"/>
+          </a:solidFill>
+          <a:ln>
+            <a:noFill/>
+          </a:ln>
+        </p:spPr>
+        <p:style>
+          <a:lnRef idx="1">
+            <a:schemeClr val="accent1"/>
+          </a:lnRef>
+          <a:fillRef idx="3">
+            <a:schemeClr val="accent1"/>
+          </a:fillRef>
+          <a:effectRef idx="2">
+            <a:schemeClr val="accent1"/>
+          </a:effectRef>
+          <a:fontRef idx="minor">
+            <a:schemeClr val="lt1"/>
+          </a:fontRef>
+        </p:style>
+        <p:txBody>
+          <a:bodyPr rtlCol="0" anchor="ctr"/>
+          <a:lstStyle/>
+          <a:p>
+            <a:pPr algn="ctr"/>
+          </a:p>
+        </p:txBody>
+      </p:sp>
+      <p:sp>
+        <p:nvSpPr>
+          <p:cNvPr id="7" name="TextBox 6"/>
+          <p:cNvSpPr txBox="1"/>
+          <p:nvPr/>
+        </p:nvSpPr>
+        <p:spPr>
+          <a:xfrm>
+            <a:off x="1097280" y="1508760"/>
+            <a:ext cx="9144000" cy="365760"/>
+          </a:xfrm>
+          <a:prstGeom prst="rect">
+            <a:avLst/>
+          </a:prstGeom>
+          <a:noFill/>
+        </p:spPr>
+        <p:txBody>
+          <a:bodyPr wrap="square">
+            <a:spAutoFit/>
+          </a:bodyPr>
+          <a:lstStyle/>
+          <a:p>
+            <a:pPr algn="l">
+              <a:defRPr sz="1400" b="1">
+                <a:solidFill>
+                  <a:srgbClr val="FF4545"/>
+                </a:solidFill>
+                <a:latin typeface="Calibri"/>
+              </a:defRPr>
+            </a:pPr>
+            <a:r>
+              <a:t>SCENARIO: TRACEABILITY LOST IN UNDER AN HOUR</a:t>
+            </a:r>
+          </a:p>
+        </p:txBody>
+      </p:sp>
+      <p:sp>
+        <p:nvSpPr>
+          <p:cNvPr id="8" name="Rounded Rectangle 7"/>
+          <p:cNvSpPr/>
+          <p:nvPr/>
+        </p:nvSpPr>
+        <p:spPr>
+          <a:xfrm>
+            <a:off x="1097280" y="1920240"/>
+            <a:ext cx="1097280" cy="320040"/>
+          </a:xfrm>
+          <a:prstGeom prst="roundRect">
+            <a:avLst/>
+          </a:prstGeom>
+          <a:solidFill>
+            <a:srgbClr val="00C97B"/>
+          </a:solidFill>
+          <a:ln>
+            <a:noFill/>
+          </a:ln>
+          <a:effectLst/>
+        </p:spPr>
+        <p:style>
+          <a:lnRef idx="1">
+            <a:schemeClr val="accent1"/>
+          </a:lnRef>
+          <a:fillRef idx="3">
+            <a:schemeClr val="accent1"/>
+          </a:fillRef>
+          <a:effectRef idx="2">
+            <a:schemeClr val="accent1"/>
+          </a:effectRef>
+          <a:fontRef idx="minor">
+            <a:schemeClr val="lt1"/>
+          </a:fontRef>
+        </p:style>
+        <p:txBody>
+          <a:bodyPr rtlCol="0" anchor="ctr"/>
+          <a:lstStyle/>
+          <a:p>
+            <a:pPr algn="ctr"/>
+          </a:p>
+        </p:txBody>
+      </p:sp>
+      <p:sp>
+        <p:nvSpPr>
+          <p:cNvPr id="9" name="TextBox 8"/>
+          <p:cNvSpPr txBox="1"/>
+          <p:nvPr/>
+        </p:nvSpPr>
+        <p:spPr>
+          <a:xfrm>
+            <a:off x="1097280" y="1938528"/>
+            <a:ext cx="1097280" cy="274320"/>
+          </a:xfrm>
+          <a:prstGeom prst="rect">
+            <a:avLst/>
+          </a:prstGeom>
+          <a:noFill/>
+        </p:spPr>
+        <p:txBody>
+          <a:bodyPr wrap="square">
+            <a:spAutoFit/>
+          </a:bodyPr>
+          <a:lstStyle/>
+          <a:p>
+            <a:pPr algn="ctr">
+              <a:defRPr sz="1100" b="1">
+                <a:solidFill>
+                  <a:srgbClr val="FFFFFF"/>
+                </a:solidFill>
+                <a:latin typeface="Calibri"/>
+              </a:defRPr>
+            </a:pPr>
+            <a:r>
+              <a:t>9:00 AM</a:t>
+            </a:r>
+          </a:p>
+        </p:txBody>
+      </p:sp>
+      <p:sp>
+        <p:nvSpPr>
+          <p:cNvPr id="10" name="TextBox 9"/>
+          <p:cNvSpPr txBox="1"/>
+          <p:nvPr/>
+        </p:nvSpPr>
+        <p:spPr>
+          <a:xfrm>
+            <a:off x="914400" y="2331720"/>
+            <a:ext cx="2286000" cy="320040"/>
+          </a:xfrm>
+          <a:prstGeom prst="rect">
+            <a:avLst/>
+          </a:prstGeom>
+          <a:noFill/>
+        </p:spPr>
+        <p:txBody>
+          <a:bodyPr wrap="square">
+            <a:spAutoFit/>
+          </a:bodyPr>
+          <a:lstStyle/>
+          <a:p>
+            <a:pPr algn="l">
+              <a:defRPr sz="1300" b="1">
+                <a:solidFill>
+                  <a:srgbClr val="00C97B"/>
+                </a:solidFill>
+                <a:latin typeface="Calibri"/>
+              </a:defRPr>
+            </a:pPr>
+            <a:r>
+              <a:t>Create branch</a:t>
+            </a:r>
+          </a:p>
+        </p:txBody>
+      </p:sp>
+      <p:sp>
+        <p:nvSpPr>
+          <p:cNvPr id="11" name="TextBox 10"/>
+          <p:cNvSpPr txBox="1"/>
+          <p:nvPr/>
+        </p:nvSpPr>
+        <p:spPr>
+          <a:xfrm>
+            <a:off x="914400" y="2651760"/>
+            <a:ext cx="2286000" cy="548640"/>
+          </a:xfrm>
+          <a:prstGeom prst="rect">
+            <a:avLst/>
+          </a:prstGeom>
+          <a:noFill/>
+        </p:spPr>
+        <p:txBody>
+          <a:bodyPr wrap="square">
+            <a:spAutoFit/>
+          </a:bodyPr>
+          <a:lstStyle/>
+          <a:p>
+            <a:pPr algn="l">
+              <a:defRPr sz="1000" b="0">
+                <a:solidFill>
+                  <a:srgbClr val="FFFFFF"/>
+                </a:solidFill>
+                <a:latin typeface="Consolas"/>
+              </a:defRPr>
+            </a:pPr>
+            <a:r>
+              <a:t>feature/IS-1234-</a:t>
+            </a:r>
+            <a:br/>
+            <a:r>
+              <a:t>add-user-profile</a:t>
+            </a:r>
+          </a:p>
+        </p:txBody>
+      </p:sp>
+      <p:sp>
+        <p:nvSpPr>
+          <p:cNvPr id="12" name="TextBox 11"/>
+          <p:cNvSpPr txBox="1"/>
+          <p:nvPr/>
+        </p:nvSpPr>
+        <p:spPr>
+          <a:xfrm>
+            <a:off x="914400" y="3246120"/>
+            <a:ext cx="2286000" cy="548640"/>
+          </a:xfrm>
+          <a:prstGeom prst="rect">
+            <a:avLst/>
+          </a:prstGeom>
+          <a:noFill/>
+        </p:spPr>
+        <p:txBody>
+          <a:bodyPr wrap="square">
+            <a:spAutoFit/>
+          </a:bodyPr>
+          <a:lstStyle/>
+          <a:p>
+            <a:pPr algn="l">
+              <a:defRPr sz="900" b="0">
+                <a:solidFill>
+                  <a:srgbClr val="BBBBCC"/>
+                </a:solidFill>
+                <a:latin typeface="Calibri"/>
+              </a:defRPr>
+            </a:pPr>
+            <a:r>
+              <a:t>Traceability exists:</a:t>
+            </a:r>
+            <a:br/>
+            <a:r>
+              <a:t>branch name links to</a:t>
+            </a:r>
+            <a:br/>
+            <a:r>
+              <a:t>user story IS-1234</a:t>
+            </a:r>
+          </a:p>
+        </p:txBody>
+      </p:sp>
+      <p:sp>
+        <p:nvSpPr>
+          <p:cNvPr id="13" name="TextBox 12"/>
+          <p:cNvSpPr txBox="1"/>
+          <p:nvPr/>
+        </p:nvSpPr>
+        <p:spPr>
+          <a:xfrm>
+            <a:off x="3154680" y="2560320"/>
+            <a:ext cx="365760" cy="365760"/>
+          </a:xfrm>
+          <a:prstGeom prst="rect">
+            <a:avLst/>
+          </a:prstGeom>
+          <a:noFill/>
+        </p:spPr>
+        <p:txBody>
+          <a:bodyPr wrap="square">
+            <a:spAutoFit/>
+          </a:bodyPr>
+          <a:lstStyle/>
+          <a:p>
+            <a:pPr algn="ctr">
+              <a:defRPr sz="2000" b="0">
+                <a:solidFill>
+                  <a:srgbClr val="888899"/>
+                </a:solidFill>
+                <a:latin typeface="Calibri"/>
+              </a:defRPr>
+            </a:pPr>
+            <a:r>
+              <a:t>→</a:t>
+            </a:r>
+          </a:p>
+        </p:txBody>
+      </p:sp>
+      <p:sp>
+        <p:nvSpPr>
+          <p:cNvPr id="14" name="Rounded Rectangle 13"/>
+          <p:cNvSpPr/>
+          <p:nvPr/>
+        </p:nvSpPr>
+        <p:spPr>
+          <a:xfrm>
+            <a:off x="3749040" y="1920240"/>
+            <a:ext cx="1097280" cy="320040"/>
+          </a:xfrm>
+          <a:prstGeom prst="roundRect">
+            <a:avLst/>
+          </a:prstGeom>
+          <a:solidFill>
+            <a:srgbClr val="008CFF"/>
+          </a:solidFill>
+          <a:ln>
+            <a:noFill/>
+          </a:ln>
+          <a:effectLst/>
+        </p:spPr>
+        <p:style>
+          <a:lnRef idx="1">
+            <a:schemeClr val="accent1"/>
+          </a:lnRef>
+          <a:fillRef idx="3">
+            <a:schemeClr val="accent1"/>
+          </a:fillRef>
+          <a:effectRef idx="2">
+            <a:schemeClr val="accent1"/>
+          </a:effectRef>
+          <a:fontRef idx="minor">
+            <a:schemeClr val="lt1"/>
+          </a:fontRef>
+        </p:style>
+        <p:txBody>
+          <a:bodyPr rtlCol="0" anchor="ctr"/>
+          <a:lstStyle/>
+          <a:p>
+            <a:pPr algn="ctr"/>
+          </a:p>
+        </p:txBody>
+      </p:sp>
+      <p:sp>
+        <p:nvSpPr>
+          <p:cNvPr id="15" name="TextBox 14"/>
+          <p:cNvSpPr txBox="1"/>
+          <p:nvPr/>
+        </p:nvSpPr>
+        <p:spPr>
+          <a:xfrm>
+            <a:off x="3749040" y="1938528"/>
+            <a:ext cx="1097280" cy="274320"/>
+          </a:xfrm>
+          <a:prstGeom prst="rect">
+            <a:avLst/>
+          </a:prstGeom>
+          <a:noFill/>
+        </p:spPr>
+        <p:txBody>
+          <a:bodyPr wrap="square">
+            <a:spAutoFit/>
+          </a:bodyPr>
+          <a:lstStyle/>
+          <a:p>
+            <a:pPr algn="ctr">
+              <a:defRPr sz="1100" b="1">
+                <a:solidFill>
+                  <a:srgbClr val="FFFFFF"/>
+                </a:solidFill>
+                <a:latin typeface="Calibri"/>
+              </a:defRPr>
+            </a:pPr>
+            <a:r>
+              <a:t>9:15 AM</a:t>
+            </a:r>
+          </a:p>
+        </p:txBody>
+      </p:sp>
+      <p:sp>
+        <p:nvSpPr>
+          <p:cNvPr id="16" name="TextBox 15"/>
+          <p:cNvSpPr txBox="1"/>
+          <p:nvPr/>
+        </p:nvSpPr>
+        <p:spPr>
+          <a:xfrm>
+            <a:off x="3566160" y="2331720"/>
+            <a:ext cx="2286000" cy="320040"/>
+          </a:xfrm>
+          <a:prstGeom prst="rect">
+            <a:avLst/>
+          </a:prstGeom>
+          <a:noFill/>
+        </p:spPr>
+        <p:txBody>
+          <a:bodyPr wrap="square">
+            <a:spAutoFit/>
+          </a:bodyPr>
+          <a:lstStyle/>
+          <a:p>
+            <a:pPr algn="l">
+              <a:defRPr sz="1300" b="1">
+                <a:solidFill>
+                  <a:srgbClr val="008CFF"/>
+                </a:solidFill>
+                <a:latin typeface="Calibri"/>
+              </a:defRPr>
+            </a:pPr>
+            <a:r>
+              <a:t>Commit work</a:t>
+            </a:r>
+          </a:p>
+        </p:txBody>
+      </p:sp>
+      <p:sp>
+        <p:nvSpPr>
+          <p:cNvPr id="17" name="TextBox 16"/>
+          <p:cNvSpPr txBox="1"/>
+          <p:nvPr/>
+        </p:nvSpPr>
+        <p:spPr>
+          <a:xfrm>
+            <a:off x="3566160" y="2651760"/>
+            <a:ext cx="2286000" cy="548640"/>
+          </a:xfrm>
+          <a:prstGeom prst="rect">
+            <a:avLst/>
+          </a:prstGeom>
+          <a:noFill/>
+        </p:spPr>
+        <p:txBody>
+          <a:bodyPr wrap="square">
+            <a:spAutoFit/>
+          </a:bodyPr>
+          <a:lstStyle/>
+          <a:p>
+            <a:pPr algn="l">
+              <a:defRPr sz="1000" b="0">
+                <a:solidFill>
+                  <a:srgbClr val="FFFFFF"/>
+                </a:solidFill>
+                <a:latin typeface="Consolas"/>
+              </a:defRPr>
+            </a:pPr>
+            <a:r>
+              <a:t>feat(user): add profile</a:t>
+            </a:r>
+            <a:br/>
+            <a:r>
+              <a:t>feat(user): add avatar</a:t>
+            </a:r>
+            <a:br/>
+            <a:r>
+              <a:t>feat(user): add settings</a:t>
+            </a:r>
+          </a:p>
+        </p:txBody>
+      </p:sp>
+      <p:sp>
+        <p:nvSpPr>
+          <p:cNvPr id="18" name="TextBox 17"/>
+          <p:cNvSpPr txBox="1"/>
+          <p:nvPr/>
+        </p:nvSpPr>
+        <p:spPr>
+          <a:xfrm>
+            <a:off x="3566160" y="3246120"/>
+            <a:ext cx="2286000" cy="548640"/>
+          </a:xfrm>
+          <a:prstGeom prst="rect">
+            <a:avLst/>
+          </a:prstGeom>
+          <a:noFill/>
+        </p:spPr>
+        <p:txBody>
+          <a:bodyPr wrap="square">
+            <a:spAutoFit/>
+          </a:bodyPr>
+          <a:lstStyle/>
+          <a:p>
+            <a:pPr algn="l">
+              <a:defRPr sz="900" b="0">
+                <a:solidFill>
+                  <a:srgbClr val="BBBBCC"/>
+                </a:solidFill>
+                <a:latin typeface="Calibri"/>
+              </a:defRPr>
+            </a:pPr>
+            <a:r>
+              <a:t>Commits reference work</a:t>
+            </a:r>
+            <a:br/>
+            <a:r>
+              <a:t>but ticket ID is only</a:t>
+            </a:r>
+            <a:br/>
+            <a:r>
+              <a:t>in the branch name</a:t>
+            </a:r>
+          </a:p>
+        </p:txBody>
+      </p:sp>
+      <p:sp>
+        <p:nvSpPr>
+          <p:cNvPr id="19" name="TextBox 18"/>
+          <p:cNvSpPr txBox="1"/>
+          <p:nvPr/>
+        </p:nvSpPr>
+        <p:spPr>
+          <a:xfrm>
+            <a:off x="5806440" y="2560320"/>
+            <a:ext cx="365760" cy="365760"/>
+          </a:xfrm>
+          <a:prstGeom prst="rect">
+            <a:avLst/>
+          </a:prstGeom>
+          <a:noFill/>
+        </p:spPr>
+        <p:txBody>
+          <a:bodyPr wrap="square">
+            <a:spAutoFit/>
+          </a:bodyPr>
+          <a:lstStyle/>
+          <a:p>
+            <a:pPr algn="ctr">
+              <a:defRPr sz="2000" b="0">
+                <a:solidFill>
+                  <a:srgbClr val="888899"/>
+                </a:solidFill>
+                <a:latin typeface="Calibri"/>
+              </a:defRPr>
+            </a:pPr>
+            <a:r>
+              <a:t>→</a:t>
+            </a:r>
+          </a:p>
+        </p:txBody>
+      </p:sp>
+      <p:sp>
+        <p:nvSpPr>
+          <p:cNvPr id="20" name="Rounded Rectangle 19"/>
+          <p:cNvSpPr/>
+          <p:nvPr/>
+        </p:nvSpPr>
+        <p:spPr>
+          <a:xfrm>
+            <a:off x="6400800" y="1920240"/>
+            <a:ext cx="1097280" cy="320040"/>
+          </a:xfrm>
+          <a:prstGeom prst="roundRect">
+            <a:avLst/>
+          </a:prstGeom>
+          <a:solidFill>
+            <a:srgbClr val="FF8C00"/>
+          </a:solidFill>
+          <a:ln>
+            <a:noFill/>
+          </a:ln>
+          <a:effectLst/>
+        </p:spPr>
+        <p:style>
+          <a:lnRef idx="1">
+            <a:schemeClr val="accent1"/>
+          </a:lnRef>
+          <a:fillRef idx="3">
+            <a:schemeClr val="accent1"/>
+          </a:fillRef>
+          <a:effectRef idx="2">
+            <a:schemeClr val="accent1"/>
+          </a:effectRef>
+          <a:fontRef idx="minor">
+            <a:schemeClr val="lt1"/>
+          </a:fontRef>
+        </p:style>
+        <p:txBody>
+          <a:bodyPr rtlCol="0" anchor="ctr"/>
+          <a:lstStyle/>
+          <a:p>
+            <a:pPr algn="ctr"/>
+          </a:p>
+        </p:txBody>
+      </p:sp>
+      <p:sp>
+        <p:nvSpPr>
+          <p:cNvPr id="21" name="TextBox 20"/>
+          <p:cNvSpPr txBox="1"/>
+          <p:nvPr/>
+        </p:nvSpPr>
+        <p:spPr>
+          <a:xfrm>
+            <a:off x="6400800" y="1938528"/>
+            <a:ext cx="1097280" cy="274320"/>
+          </a:xfrm>
+          <a:prstGeom prst="rect">
+            <a:avLst/>
+          </a:prstGeom>
+          <a:noFill/>
+        </p:spPr>
+        <p:txBody>
+          <a:bodyPr wrap="square">
+            <a:spAutoFit/>
+          </a:bodyPr>
+          <a:lstStyle/>
+          <a:p>
+            <a:pPr algn="ctr">
+              <a:defRPr sz="1100" b="1">
+                <a:solidFill>
+                  <a:srgbClr val="FFFFFF"/>
+                </a:solidFill>
+                <a:latin typeface="Calibri"/>
+              </a:defRPr>
+            </a:pPr>
+            <a:r>
+              <a:t>9:30 AM</a:t>
+            </a:r>
+          </a:p>
+        </p:txBody>
+      </p:sp>
+      <p:sp>
+        <p:nvSpPr>
+          <p:cNvPr id="22" name="TextBox 21"/>
+          <p:cNvSpPr txBox="1"/>
+          <p:nvPr/>
+        </p:nvSpPr>
+        <p:spPr>
+          <a:xfrm>
+            <a:off x="6217920" y="2331720"/>
+            <a:ext cx="2286000" cy="320040"/>
+          </a:xfrm>
+          <a:prstGeom prst="rect">
+            <a:avLst/>
+          </a:prstGeom>
+          <a:noFill/>
+        </p:spPr>
+        <p:txBody>
+          <a:bodyPr wrap="square">
+            <a:spAutoFit/>
+          </a:bodyPr>
+          <a:lstStyle/>
+          <a:p>
+            <a:pPr algn="l">
+              <a:defRPr sz="1300" b="1">
+                <a:solidFill>
+                  <a:srgbClr val="FF8C00"/>
+                </a:solidFill>
+                <a:latin typeface="Calibri"/>
+              </a:defRPr>
+            </a:pPr>
+            <a:r>
+              <a:t>Squash-merge PR</a:t>
+            </a:r>
+          </a:p>
+        </p:txBody>
+      </p:sp>
+      <p:sp>
+        <p:nvSpPr>
+          <p:cNvPr id="23" name="TextBox 22"/>
+          <p:cNvSpPr txBox="1"/>
+          <p:nvPr/>
+        </p:nvSpPr>
+        <p:spPr>
+          <a:xfrm>
+            <a:off x="6217920" y="2651760"/>
+            <a:ext cx="2286000" cy="548640"/>
+          </a:xfrm>
+          <a:prstGeom prst="rect">
+            <a:avLst/>
+          </a:prstGeom>
+          <a:noFill/>
+        </p:spPr>
+        <p:txBody>
+          <a:bodyPr wrap="square">
+            <a:spAutoFit/>
+          </a:bodyPr>
+          <a:lstStyle/>
+          <a:p>
+            <a:pPr algn="l">
+              <a:defRPr sz="1000" b="0">
+                <a:solidFill>
+                  <a:srgbClr val="FFFFFF"/>
+                </a:solidFill>
+                <a:latin typeface="Consolas"/>
+              </a:defRPr>
+            </a:pPr>
+            <a:r>
+              <a:t>Merge PR #42</a:t>
+            </a:r>
+            <a:br/>
+            <a:r>
+              <a:t>Branch auto-deleted</a:t>
+            </a:r>
+          </a:p>
+        </p:txBody>
+      </p:sp>
+      <p:sp>
+        <p:nvSpPr>
+          <p:cNvPr id="24" name="TextBox 23"/>
+          <p:cNvSpPr txBox="1"/>
+          <p:nvPr/>
+        </p:nvSpPr>
+        <p:spPr>
+          <a:xfrm>
+            <a:off x="6217920" y="3246120"/>
+            <a:ext cx="2286000" cy="548640"/>
+          </a:xfrm>
+          <a:prstGeom prst="rect">
+            <a:avLst/>
+          </a:prstGeom>
+          <a:noFill/>
+        </p:spPr>
+        <p:txBody>
+          <a:bodyPr wrap="square">
+            <a:spAutoFit/>
+          </a:bodyPr>
+          <a:lstStyle/>
+          <a:p>
+            <a:pPr algn="l">
+              <a:defRPr sz="900" b="0">
+                <a:solidFill>
+                  <a:srgbClr val="BBBBCC"/>
+                </a:solidFill>
+                <a:latin typeface="Calibri"/>
+              </a:defRPr>
+            </a:pPr>
+            <a:r>
+              <a:t>Branch name gone.</a:t>
+            </a:r>
+            <a:br/>
+            <a:r>
+              <a:t>Ticket ID only in</a:t>
+            </a:r>
+            <a:br/>
+            <a:r>
+              <a:t>GitHub PR metadata</a:t>
+            </a:r>
+          </a:p>
+        </p:txBody>
+      </p:sp>
+      <p:sp>
+        <p:nvSpPr>
+          <p:cNvPr id="25" name="TextBox 24"/>
+          <p:cNvSpPr txBox="1"/>
+          <p:nvPr/>
+        </p:nvSpPr>
+        <p:spPr>
+          <a:xfrm>
+            <a:off x="8458200" y="2560320"/>
+            <a:ext cx="365760" cy="365760"/>
+          </a:xfrm>
+          <a:prstGeom prst="rect">
+            <a:avLst/>
+          </a:prstGeom>
+          <a:noFill/>
+        </p:spPr>
+        <p:txBody>
+          <a:bodyPr wrap="square">
+            <a:spAutoFit/>
+          </a:bodyPr>
+          <a:lstStyle/>
+          <a:p>
+            <a:pPr algn="ctr">
+              <a:defRPr sz="2000" b="0">
+                <a:solidFill>
+                  <a:srgbClr val="888899"/>
+                </a:solidFill>
+                <a:latin typeface="Calibri"/>
+              </a:defRPr>
+            </a:pPr>
+            <a:r>
+              <a:t>→</a:t>
+            </a:r>
+          </a:p>
+        </p:txBody>
+      </p:sp>
+      <p:sp>
+        <p:nvSpPr>
+          <p:cNvPr id="26" name="Rounded Rectangle 25"/>
+          <p:cNvSpPr/>
+          <p:nvPr/>
+        </p:nvSpPr>
+        <p:spPr>
+          <a:xfrm>
+            <a:off x="9052560" y="1920240"/>
+            <a:ext cx="1097280" cy="320040"/>
+          </a:xfrm>
+          <a:prstGeom prst="roundRect">
+            <a:avLst/>
+          </a:prstGeom>
+          <a:solidFill>
+            <a:srgbClr val="FF4545"/>
+          </a:solidFill>
+          <a:ln>
+            <a:noFill/>
+          </a:ln>
+          <a:effectLst/>
+        </p:spPr>
+        <p:style>
+          <a:lnRef idx="1">
+            <a:schemeClr val="accent1"/>
+          </a:lnRef>
+          <a:fillRef idx="3">
+            <a:schemeClr val="accent1"/>
+          </a:fillRef>
+          <a:effectRef idx="2">
+            <a:schemeClr val="accent1"/>
+          </a:effectRef>
+          <a:fontRef idx="minor">
+            <a:schemeClr val="lt1"/>
+          </a:fontRef>
+        </p:style>
+        <p:txBody>
+          <a:bodyPr rtlCol="0" anchor="ctr"/>
+          <a:lstStyle/>
+          <a:p>
+            <a:pPr algn="ctr"/>
+          </a:p>
+        </p:txBody>
+      </p:sp>
+      <p:sp>
+        <p:nvSpPr>
+          <p:cNvPr id="27" name="TextBox 26"/>
+          <p:cNvSpPr txBox="1"/>
+          <p:nvPr/>
+        </p:nvSpPr>
+        <p:spPr>
+          <a:xfrm>
+            <a:off x="9052560" y="1938528"/>
+            <a:ext cx="1097280" cy="274320"/>
+          </a:xfrm>
+          <a:prstGeom prst="rect">
+            <a:avLst/>
+          </a:prstGeom>
+          <a:noFill/>
+        </p:spPr>
+        <p:txBody>
+          <a:bodyPr wrap="square">
+            <a:spAutoFit/>
+          </a:bodyPr>
+          <a:lstStyle/>
+          <a:p>
+            <a:pPr algn="ctr">
+              <a:defRPr sz="1100" b="1">
+                <a:solidFill>
+                  <a:srgbClr val="FFFFFF"/>
+                </a:solidFill>
+                <a:latin typeface="Calibri"/>
+              </a:defRPr>
+            </a:pPr>
+            <a:r>
+              <a:t>9:45 AM</a:t>
+            </a:r>
+          </a:p>
+        </p:txBody>
+      </p:sp>
+      <p:sp>
+        <p:nvSpPr>
+          <p:cNvPr id="28" name="TextBox 27"/>
+          <p:cNvSpPr txBox="1"/>
+          <p:nvPr/>
+        </p:nvSpPr>
+        <p:spPr>
+          <a:xfrm>
+            <a:off x="8869680" y="2331720"/>
+            <a:ext cx="2286000" cy="320040"/>
+          </a:xfrm>
+          <a:prstGeom prst="rect">
+            <a:avLst/>
+          </a:prstGeom>
+          <a:noFill/>
+        </p:spPr>
+        <p:txBody>
+          <a:bodyPr wrap="square">
+            <a:spAutoFit/>
+          </a:bodyPr>
+          <a:lstStyle/>
+          <a:p>
+            <a:pPr algn="l">
+              <a:defRPr sz="1300" b="1">
+                <a:solidFill>
+                  <a:srgbClr val="FF4545"/>
+                </a:solidFill>
+                <a:latin typeface="Calibri"/>
+              </a:defRPr>
+            </a:pPr>
+            <a:r>
+              <a:t>Audit question</a:t>
+            </a:r>
+          </a:p>
+        </p:txBody>
+      </p:sp>
+      <p:sp>
+        <p:nvSpPr>
+          <p:cNvPr id="29" name="TextBox 28"/>
+          <p:cNvSpPr txBox="1"/>
+          <p:nvPr/>
+        </p:nvSpPr>
+        <p:spPr>
+          <a:xfrm>
+            <a:off x="8869680" y="2651760"/>
+            <a:ext cx="2286000" cy="548640"/>
+          </a:xfrm>
+          <a:prstGeom prst="rect">
+            <a:avLst/>
+          </a:prstGeom>
+          <a:noFill/>
+        </p:spPr>
+        <p:txBody>
+          <a:bodyPr wrap="square">
+            <a:spAutoFit/>
+          </a:bodyPr>
+          <a:lstStyle/>
+          <a:p>
+            <a:pPr algn="l">
+              <a:defRPr sz="1000" b="0">
+                <a:solidFill>
+                  <a:srgbClr val="FFFFFF"/>
+                </a:solidFill>
+                <a:latin typeface="Consolas"/>
+              </a:defRPr>
+            </a:pPr>
+            <a:r>
+              <a:t>"What code changed</a:t>
+            </a:r>
+            <a:br/>
+            <a:r>
+              <a:t>for IS-1234?"</a:t>
+            </a:r>
+          </a:p>
+        </p:txBody>
+      </p:sp>
+      <p:sp>
+        <p:nvSpPr>
+          <p:cNvPr id="30" name="TextBox 29"/>
+          <p:cNvSpPr txBox="1"/>
+          <p:nvPr/>
+        </p:nvSpPr>
+        <p:spPr>
+          <a:xfrm>
+            <a:off x="8869680" y="3246120"/>
+            <a:ext cx="2286000" cy="548640"/>
+          </a:xfrm>
+          <a:prstGeom prst="rect">
+            <a:avLst/>
+          </a:prstGeom>
+          <a:noFill/>
+        </p:spPr>
+        <p:txBody>
+          <a:bodyPr wrap="square">
+            <a:spAutoFit/>
+          </a:bodyPr>
+          <a:lstStyle/>
+          <a:p>
+            <a:pPr algn="l">
+              <a:defRPr sz="900" b="0">
+                <a:solidFill>
+                  <a:srgbClr val="BBBBCC"/>
+                </a:solidFill>
+                <a:latin typeface="Calibri"/>
+              </a:defRPr>
+            </a:pPr>
+            <a:r>
+              <a:t>Must search GitHub</a:t>
+            </a:r>
+            <a:br/>
+            <a:r>
+              <a:t>PR metadata — not in</a:t>
+            </a:r>
+            <a:br/>
+            <a:r>
+              <a:t>Git history itself</a:t>
+            </a:r>
+          </a:p>
+        </p:txBody>
+      </p:sp>
+      <p:sp>
+        <p:nvSpPr>
+          <p:cNvPr id="31" name="Rounded Rectangle 30"/>
+          <p:cNvSpPr/>
+          <p:nvPr/>
+        </p:nvSpPr>
+        <p:spPr>
+          <a:xfrm>
+            <a:off x="731520" y="4023360"/>
+            <a:ext cx="5029200" cy="2560320"/>
+          </a:xfrm>
+          <a:prstGeom prst="roundRect">
+            <a:avLst/>
+          </a:prstGeom>
+          <a:solidFill>
+            <a:srgbClr val="26263E"/>
+          </a:solidFill>
+          <a:ln>
+            <a:noFill/>
+          </a:ln>
+          <a:effectLst/>
+        </p:spPr>
+        <p:style>
+          <a:lnRef idx="1">
+            <a:schemeClr val="accent1"/>
+          </a:lnRef>
+          <a:fillRef idx="3">
+            <a:schemeClr val="accent1"/>
+          </a:fillRef>
+          <a:effectRef idx="2">
+            <a:schemeClr val="accent1"/>
+          </a:effectRef>
+          <a:fontRef idx="minor">
+            <a:schemeClr val="lt1"/>
+          </a:fontRef>
+        </p:style>
+        <p:txBody>
+          <a:bodyPr rtlCol="0" anchor="ctr"/>
+          <a:lstStyle/>
+          <a:p>
+            <a:pPr algn="ctr"/>
+          </a:p>
+        </p:txBody>
+      </p:sp>
+      <p:sp>
+        <p:nvSpPr>
+          <p:cNvPr id="32" name="Rectangle 31"/>
+          <p:cNvSpPr/>
+          <p:nvPr/>
+        </p:nvSpPr>
+        <p:spPr>
+          <a:xfrm>
+            <a:off x="731520" y="4023360"/>
+            <a:ext cx="73152" cy="2560320"/>
+          </a:xfrm>
+          <a:prstGeom prst="rect">
+            <a:avLst/>
+          </a:prstGeom>
+          <a:solidFill>
+            <a:srgbClr val="FF4545"/>
+          </a:solidFill>
+          <a:ln>
+            <a:noFill/>
+          </a:ln>
+        </p:spPr>
+        <p:style>
+          <a:lnRef idx="1">
+            <a:schemeClr val="accent1"/>
+          </a:lnRef>
+          <a:fillRef idx="3">
+            <a:schemeClr val="accent1"/>
+          </a:fillRef>
+          <a:effectRef idx="2">
+            <a:schemeClr val="accent1"/>
+          </a:effectRef>
+          <a:fontRef idx="minor">
+            <a:schemeClr val="lt1"/>
+          </a:fontRef>
+        </p:style>
+        <p:txBody>
+          <a:bodyPr rtlCol="0" anchor="ctr"/>
+          <a:lstStyle/>
+          <a:p>
+            <a:pPr algn="ctr"/>
+          </a:p>
+        </p:txBody>
+      </p:sp>
+      <p:sp>
+        <p:nvSpPr>
+          <p:cNvPr id="33" name="TextBox 32"/>
+          <p:cNvSpPr txBox="1"/>
+          <p:nvPr/>
+        </p:nvSpPr>
+        <p:spPr>
+          <a:xfrm>
+            <a:off x="1097280" y="4114800"/>
+            <a:ext cx="4389120" cy="365760"/>
+          </a:xfrm>
+          <a:prstGeom prst="rect">
+            <a:avLst/>
+          </a:prstGeom>
+          <a:noFill/>
+        </p:spPr>
+        <p:txBody>
+          <a:bodyPr wrap="square">
+            <a:spAutoFit/>
+          </a:bodyPr>
+          <a:lstStyle/>
+          <a:p>
+            <a:pPr algn="l">
+              <a:defRPr sz="1400" b="1">
+                <a:solidFill>
+                  <a:srgbClr val="FF4545"/>
+                </a:solidFill>
+                <a:latin typeface="Calibri"/>
+              </a:defRPr>
+            </a:pPr>
+            <a:r>
+              <a:t>WHY TRACEABILITY BREAKS</a:t>
+            </a:r>
+          </a:p>
+        </p:txBody>
+      </p:sp>
+      <p:sp>
+        <p:nvSpPr>
+          <p:cNvPr id="34" name="TextBox 33"/>
+          <p:cNvSpPr txBox="1"/>
+          <p:nvPr/>
+        </p:nvSpPr>
+        <p:spPr>
+          <a:xfrm>
+            <a:off x="1188720" y="4572000"/>
+            <a:ext cx="4389120" cy="274320"/>
+          </a:xfrm>
+          <a:prstGeom prst="rect">
+            <a:avLst/>
+          </a:prstGeom>
+          <a:noFill/>
+        </p:spPr>
+        <p:txBody>
+          <a:bodyPr wrap="square">
+            <a:spAutoFit/>
+          </a:bodyPr>
+          <a:lstStyle/>
+          <a:p>
+            <a:pPr algn="l">
+              <a:defRPr sz="1200" b="1">
+                <a:solidFill>
+                  <a:srgbClr val="FF8C00"/>
+                </a:solidFill>
+                <a:latin typeface="Calibri"/>
+              </a:defRPr>
+            </a:pPr>
+            <a:r>
+              <a:t>✗  Branches are not immutable</a:t>
+            </a:r>
+          </a:p>
+        </p:txBody>
+      </p:sp>
+      <p:sp>
+        <p:nvSpPr>
+          <p:cNvPr id="35" name="TextBox 34"/>
+          <p:cNvSpPr txBox="1"/>
+          <p:nvPr/>
+        </p:nvSpPr>
+        <p:spPr>
+          <a:xfrm>
+            <a:off x="1371600" y="4828032"/>
+            <a:ext cx="4114800" cy="457200"/>
+          </a:xfrm>
+          <a:prstGeom prst="rect">
+            <a:avLst/>
+          </a:prstGeom>
+          <a:noFill/>
+        </p:spPr>
+        <p:txBody>
+          <a:bodyPr wrap="square">
+            <a:spAutoFit/>
+          </a:bodyPr>
+          <a:lstStyle/>
+          <a:p>
+            <a:pPr algn="l">
+              <a:defRPr sz="1000" b="0">
+                <a:solidFill>
+                  <a:srgbClr val="BBBBCC"/>
+                </a:solidFill>
+                <a:latin typeface="Calibri"/>
+              </a:defRPr>
+            </a:pPr>
+            <a:r>
+              <a:t>A Git branch is just a pointer — it can be</a:t>
+            </a:r>
+            <a:br/>
+            <a:r>
+              <a:t>created, renamed, or deleted at any time.</a:t>
+            </a:r>
+            <a:br/>
+            <a:r>
+              <a:t>There is no durable record that it ever existed.</a:t>
+            </a:r>
+          </a:p>
+        </p:txBody>
+      </p:sp>
+      <p:sp>
+        <p:nvSpPr>
+          <p:cNvPr id="36" name="TextBox 35"/>
+          <p:cNvSpPr txBox="1"/>
+          <p:nvPr/>
+        </p:nvSpPr>
+        <p:spPr>
+          <a:xfrm>
+            <a:off x="1188720" y="5230368"/>
+            <a:ext cx="4389120" cy="274320"/>
+          </a:xfrm>
+          <a:prstGeom prst="rect">
+            <a:avLst/>
+          </a:prstGeom>
+          <a:noFill/>
+        </p:spPr>
+        <p:txBody>
+          <a:bodyPr wrap="square">
+            <a:spAutoFit/>
+          </a:bodyPr>
+          <a:lstStyle/>
+          <a:p>
+            <a:pPr algn="l">
+              <a:defRPr sz="1200" b="1">
+                <a:solidFill>
+                  <a:srgbClr val="FF8C00"/>
+                </a:solidFill>
+                <a:latin typeface="Calibri"/>
+              </a:defRPr>
+            </a:pPr>
+            <a:r>
+              <a:t>✗  Deletion is the standard practice</a:t>
+            </a:r>
+          </a:p>
+        </p:txBody>
+      </p:sp>
+      <p:sp>
+        <p:nvSpPr>
+          <p:cNvPr id="37" name="TextBox 36"/>
+          <p:cNvSpPr txBox="1"/>
+          <p:nvPr/>
+        </p:nvSpPr>
+        <p:spPr>
+          <a:xfrm>
+            <a:off x="1371600" y="5486400"/>
+            <a:ext cx="4114800" cy="457200"/>
+          </a:xfrm>
+          <a:prstGeom prst="rect">
+            <a:avLst/>
+          </a:prstGeom>
+          <a:noFill/>
+        </p:spPr>
+        <p:txBody>
+          <a:bodyPr wrap="square">
+            <a:spAutoFit/>
+          </a:bodyPr>
+          <a:lstStyle/>
+          <a:p>
+            <a:pPr algn="l">
+              <a:defRPr sz="1000" b="0">
+                <a:solidFill>
+                  <a:srgbClr val="BBBBCC"/>
+                </a:solidFill>
+                <a:latin typeface="Calibri"/>
+              </a:defRPr>
+            </a:pPr>
+            <a:r>
+              <a:t>Our own standard says "delete branch after merge."</a:t>
+            </a:r>
+            <a:br/>
+            <a:r>
+              <a:t>This means the ticket ID in the branch name is</a:t>
+            </a:r>
+            <a:br/>
+            <a:r>
+              <a:t>intentionally destroyed as part of the workflow.</a:t>
+            </a:r>
+          </a:p>
+        </p:txBody>
+      </p:sp>
+      <p:sp>
+        <p:nvSpPr>
+          <p:cNvPr id="38" name="TextBox 37"/>
+          <p:cNvSpPr txBox="1"/>
+          <p:nvPr/>
+        </p:nvSpPr>
+        <p:spPr>
+          <a:xfrm>
+            <a:off x="1188720" y="5888736"/>
+            <a:ext cx="4389120" cy="274320"/>
+          </a:xfrm>
+          <a:prstGeom prst="rect">
+            <a:avLst/>
+          </a:prstGeom>
+          <a:noFill/>
+        </p:spPr>
+        <p:txBody>
+          <a:bodyPr wrap="square">
+            <a:spAutoFit/>
+          </a:bodyPr>
+          <a:lstStyle/>
+          <a:p>
+            <a:pPr algn="l">
+              <a:defRPr sz="1200" b="1">
+                <a:solidFill>
+                  <a:srgbClr val="FF8C00"/>
+                </a:solidFill>
+                <a:latin typeface="Calibri"/>
+              </a:defRPr>
+            </a:pPr>
+            <a:r>
+              <a:t>✗  Squash-merge erases branch context</a:t>
+            </a:r>
+          </a:p>
+        </p:txBody>
+      </p:sp>
+      <p:sp>
+        <p:nvSpPr>
+          <p:cNvPr id="39" name="TextBox 38"/>
+          <p:cNvSpPr txBox="1"/>
+          <p:nvPr/>
+        </p:nvSpPr>
+        <p:spPr>
+          <a:xfrm>
+            <a:off x="1371600" y="6144768"/>
+            <a:ext cx="4114800" cy="457200"/>
+          </a:xfrm>
+          <a:prstGeom prst="rect">
+            <a:avLst/>
+          </a:prstGeom>
+          <a:noFill/>
+        </p:spPr>
+        <p:txBody>
+          <a:bodyPr wrap="square">
+            <a:spAutoFit/>
+          </a:bodyPr>
+          <a:lstStyle/>
+          <a:p>
+            <a:pPr algn="l">
+              <a:defRPr sz="1000" b="0">
+                <a:solidFill>
+                  <a:srgbClr val="BBBBCC"/>
+                </a:solidFill>
+                <a:latin typeface="Calibri"/>
+              </a:defRPr>
+            </a:pPr>
+            <a:r>
+              <a:t>The squash commit on main contains no reference</a:t>
+            </a:r>
+            <a:br/>
+            <a:r>
+              <a:t>to the original branch name or its ticket ID.</a:t>
+            </a:r>
+            <a:br/>
+            <a:r>
+              <a:t>The link only survives in GitHub's PR metadata.</a:t>
+            </a:r>
+          </a:p>
+        </p:txBody>
+      </p:sp>
+      <p:sp>
+        <p:nvSpPr>
+          <p:cNvPr id="40" name="Rounded Rectangle 39"/>
+          <p:cNvSpPr/>
+          <p:nvPr/>
+        </p:nvSpPr>
+        <p:spPr>
+          <a:xfrm>
+            <a:off x="6217920" y="4023360"/>
+            <a:ext cx="5029200" cy="2560320"/>
+          </a:xfrm>
+          <a:prstGeom prst="roundRect">
+            <a:avLst/>
+          </a:prstGeom>
+          <a:solidFill>
+            <a:srgbClr val="26263E"/>
+          </a:solidFill>
+          <a:ln>
+            <a:noFill/>
+          </a:ln>
+          <a:effectLst/>
+        </p:spPr>
+        <p:style>
+          <a:lnRef idx="1">
+            <a:schemeClr val="accent1"/>
+          </a:lnRef>
+          <a:fillRef idx="3">
+            <a:schemeClr val="accent1"/>
+          </a:fillRef>
+          <a:effectRef idx="2">
+            <a:schemeClr val="accent1"/>
+          </a:effectRef>
+          <a:fontRef idx="minor">
+            <a:schemeClr val="lt1"/>
+          </a:fontRef>
+        </p:style>
+        <p:txBody>
+          <a:bodyPr rtlCol="0" anchor="ctr"/>
+          <a:lstStyle/>
+          <a:p>
+            <a:pPr algn="ctr"/>
+          </a:p>
+        </p:txBody>
+      </p:sp>
+      <p:sp>
+        <p:nvSpPr>
+          <p:cNvPr id="41" name="Rectangle 40"/>
+          <p:cNvSpPr/>
+          <p:nvPr/>
+        </p:nvSpPr>
+        <p:spPr>
+          <a:xfrm>
+            <a:off x="6217920" y="4023360"/>
+            <a:ext cx="73152" cy="2560320"/>
+          </a:xfrm>
+          <a:prstGeom prst="rect">
+            <a:avLst/>
+          </a:prstGeom>
+          <a:solidFill>
+            <a:srgbClr val="00C97B"/>
+          </a:solidFill>
+          <a:ln>
+            <a:noFill/>
+          </a:ln>
+        </p:spPr>
+        <p:style>
+          <a:lnRef idx="1">
+            <a:schemeClr val="accent1"/>
+          </a:lnRef>
+          <a:fillRef idx="3">
+            <a:schemeClr val="accent1"/>
+          </a:fillRef>
+          <a:effectRef idx="2">
+            <a:schemeClr val="accent1"/>
+          </a:effectRef>
+          <a:fontRef idx="minor">
+            <a:schemeClr val="lt1"/>
+          </a:fontRef>
+        </p:style>
+        <p:txBody>
+          <a:bodyPr rtlCol="0" anchor="ctr"/>
+          <a:lstStyle/>
+          <a:p>
+            <a:pPr algn="ctr"/>
+          </a:p>
+        </p:txBody>
+      </p:sp>
+      <p:sp>
+        <p:nvSpPr>
+          <p:cNvPr id="42" name="TextBox 41"/>
+          <p:cNvSpPr txBox="1"/>
+          <p:nvPr/>
+        </p:nvSpPr>
+        <p:spPr>
+          <a:xfrm>
+            <a:off x="6583680" y="4114800"/>
+            <a:ext cx="3200400" cy="365760"/>
+          </a:xfrm>
+          <a:prstGeom prst="rect">
+            <a:avLst/>
+          </a:prstGeom>
+          <a:noFill/>
+        </p:spPr>
+        <p:txBody>
+          <a:bodyPr wrap="square">
+            <a:spAutoFit/>
+          </a:bodyPr>
+          <a:lstStyle/>
+          <a:p>
+            <a:pPr algn="l">
+              <a:defRPr sz="1400" b="1">
+                <a:solidFill>
+                  <a:srgbClr val="00C97B"/>
+                </a:solidFill>
+                <a:latin typeface="Calibri"/>
+              </a:defRPr>
+            </a:pPr>
+            <a:r>
+              <a:t>PROPOSED SOLUTION</a:t>
+            </a:r>
+          </a:p>
+        </p:txBody>
+      </p:sp>
+      <p:sp>
+        <p:nvSpPr>
+          <p:cNvPr id="43" name="Rounded Rectangle 42"/>
+          <p:cNvSpPr/>
+          <p:nvPr/>
+        </p:nvSpPr>
+        <p:spPr>
+          <a:xfrm>
+            <a:off x="9601200" y="4114800"/>
+            <a:ext cx="1463040" cy="320040"/>
+          </a:xfrm>
+          <a:prstGeom prst="roundRect">
+            <a:avLst/>
+          </a:prstGeom>
+          <a:solidFill>
+            <a:srgbClr val="FF8C00"/>
+          </a:solidFill>
+          <a:ln>
+            <a:noFill/>
+          </a:ln>
+          <a:effectLst/>
+        </p:spPr>
+        <p:style>
+          <a:lnRef idx="1">
+            <a:schemeClr val="accent1"/>
+          </a:lnRef>
+          <a:fillRef idx="3">
+            <a:schemeClr val="accent1"/>
+          </a:fillRef>
+          <a:effectRef idx="2">
+            <a:schemeClr val="accent1"/>
+          </a:effectRef>
+          <a:fontRef idx="minor">
+            <a:schemeClr val="lt1"/>
+          </a:fontRef>
+        </p:style>
+        <p:txBody>
+          <a:bodyPr rtlCol="0" anchor="ctr"/>
+          <a:lstStyle/>
+          <a:p>
+            <a:pPr algn="ctr"/>
+          </a:p>
+        </p:txBody>
+      </p:sp>
+      <p:sp>
+        <p:nvSpPr>
+          <p:cNvPr id="44" name="TextBox 43"/>
+          <p:cNvSpPr txBox="1"/>
+          <p:nvPr/>
+        </p:nvSpPr>
+        <p:spPr>
+          <a:xfrm>
+            <a:off x="9601200" y="4133087"/>
+            <a:ext cx="1463040" cy="274320"/>
+          </a:xfrm>
+          <a:prstGeom prst="rect">
+            <a:avLst/>
+          </a:prstGeom>
+          <a:noFill/>
+        </p:spPr>
+        <p:txBody>
+          <a:bodyPr wrap="square">
+            <a:spAutoFit/>
+          </a:bodyPr>
+          <a:lstStyle/>
+          <a:p>
+            <a:pPr algn="ctr">
+              <a:defRPr sz="1100" b="1">
+                <a:solidFill>
+                  <a:srgbClr val="FFFFFF"/>
+                </a:solidFill>
+                <a:latin typeface="Calibri"/>
+              </a:defRPr>
+            </a:pPr>
+            <a:r>
+              <a:t>TO BE EXPLORED</a:t>
+            </a:r>
+          </a:p>
+        </p:txBody>
+      </p:sp>
+      <p:sp>
+        <p:nvSpPr>
+          <p:cNvPr id="45" name="TextBox 44"/>
+          <p:cNvSpPr txBox="1"/>
+          <p:nvPr/>
+        </p:nvSpPr>
+        <p:spPr>
+          <a:xfrm>
+            <a:off x="6583680" y="4526280"/>
+            <a:ext cx="4389120" cy="457200"/>
+          </a:xfrm>
+          <a:prstGeom prst="rect">
+            <a:avLst/>
+          </a:prstGeom>
+          <a:noFill/>
+        </p:spPr>
+        <p:txBody>
+          <a:bodyPr wrap="square">
+            <a:spAutoFit/>
+          </a:bodyPr>
+          <a:lstStyle/>
+          <a:p>
+            <a:pPr algn="l">
+              <a:defRPr sz="1500" b="1">
+                <a:solidFill>
+                  <a:srgbClr val="FFFFFF"/>
+                </a:solidFill>
+                <a:latin typeface="Calibri"/>
+              </a:defRPr>
+            </a:pPr>
+            <a:r>
+              <a:t>CI Integration with Audit Logs on Every Branch</a:t>
+            </a:r>
+          </a:p>
+        </p:txBody>
+      </p:sp>
+      <p:sp>
+        <p:nvSpPr>
+          <p:cNvPr id="46" name="TextBox 45"/>
+          <p:cNvSpPr txBox="1"/>
+          <p:nvPr/>
+        </p:nvSpPr>
+        <p:spPr>
+          <a:xfrm>
+            <a:off x="6583680" y="4937760"/>
+            <a:ext cx="4389120" cy="548640"/>
+          </a:xfrm>
+          <a:prstGeom prst="rect">
+            <a:avLst/>
+          </a:prstGeom>
+          <a:noFill/>
+        </p:spPr>
+        <p:txBody>
+          <a:bodyPr wrap="square">
+            <a:spAutoFit/>
+          </a:bodyPr>
+          <a:lstStyle/>
+          <a:p>
+            <a:pPr algn="l">
+              <a:defRPr sz="1200" b="0">
+                <a:solidFill>
+                  <a:srgbClr val="BBBBCC"/>
+                </a:solidFill>
+                <a:latin typeface="Calibri"/>
+              </a:defRPr>
+            </a:pPr>
+            <a:r>
+              <a:t>We need a CI integration that maintains audit logs</a:t>
+            </a:r>
+            <a:br/>
+            <a:r>
+              <a:t>on every branch — capturing the full lifecycle of</a:t>
+            </a:r>
+            <a:br/>
+            <a:r>
+              <a:t>development work tied to each user story.</a:t>
+            </a:r>
+          </a:p>
+        </p:txBody>
+      </p:sp>
+      <p:sp>
+        <p:nvSpPr>
+          <p:cNvPr id="47" name="TextBox 46"/>
+          <p:cNvSpPr txBox="1"/>
+          <p:nvPr/>
+        </p:nvSpPr>
+        <p:spPr>
+          <a:xfrm>
+            <a:off x="6583680" y="5440680"/>
+            <a:ext cx="4389120" cy="320040"/>
+          </a:xfrm>
+          <a:prstGeom prst="rect">
+            <a:avLst/>
+          </a:prstGeom>
+          <a:noFill/>
+        </p:spPr>
+        <p:txBody>
+          <a:bodyPr wrap="square">
+            <a:spAutoFit/>
+          </a:bodyPr>
+          <a:lstStyle/>
+          <a:p>
+            <a:pPr algn="l">
+              <a:defRPr sz="1100" b="1">
+                <a:solidFill>
+                  <a:srgbClr val="00C97B"/>
+                </a:solidFill>
+                <a:latin typeface="Calibri"/>
+              </a:defRPr>
+            </a:pPr>
+            <a:r>
+              <a:t>CI must log:</a:t>
+            </a:r>
+          </a:p>
+        </p:txBody>
+      </p:sp>
+      <p:sp>
+        <p:nvSpPr>
+          <p:cNvPr id="48" name="TextBox 47"/>
+          <p:cNvSpPr txBox="1"/>
+          <p:nvPr/>
+        </p:nvSpPr>
+        <p:spPr>
+          <a:xfrm>
+            <a:off x="6766560" y="5760720"/>
+            <a:ext cx="4114800" cy="228600"/>
+          </a:xfrm>
+          <a:prstGeom prst="rect">
+            <a:avLst/>
+          </a:prstGeom>
+          <a:noFill/>
+        </p:spPr>
+        <p:txBody>
+          <a:bodyPr wrap="square">
+            <a:spAutoFit/>
+          </a:bodyPr>
+          <a:lstStyle/>
+          <a:p>
+            <a:pPr algn="l">
+              <a:defRPr sz="1000" b="0">
+                <a:solidFill>
+                  <a:srgbClr val="BBBBCC"/>
+                </a:solidFill>
+                <a:latin typeface="Consolas"/>
+              </a:defRPr>
+            </a:pPr>
+            <a:r>
+              <a:t>Branch created  →  who, when, which user story</a:t>
+            </a:r>
+          </a:p>
+        </p:txBody>
+      </p:sp>
+      <p:sp>
+        <p:nvSpPr>
+          <p:cNvPr id="49" name="TextBox 48"/>
+          <p:cNvSpPr txBox="1"/>
+          <p:nvPr/>
+        </p:nvSpPr>
+        <p:spPr>
+          <a:xfrm>
+            <a:off x="6766560" y="5989320"/>
+            <a:ext cx="4114800" cy="228600"/>
+          </a:xfrm>
+          <a:prstGeom prst="rect">
+            <a:avLst/>
+          </a:prstGeom>
+          <a:noFill/>
+        </p:spPr>
+        <p:txBody>
+          <a:bodyPr wrap="square">
+            <a:spAutoFit/>
+          </a:bodyPr>
+          <a:lstStyle/>
+          <a:p>
+            <a:pPr algn="l">
+              <a:defRPr sz="1000" b="0">
+                <a:solidFill>
+                  <a:srgbClr val="BBBBCC"/>
+                </a:solidFill>
+                <a:latin typeface="Consolas"/>
+              </a:defRPr>
+            </a:pPr>
+            <a:r>
+              <a:t>Every push       →  commits, changes, author</a:t>
+            </a:r>
+          </a:p>
+        </p:txBody>
+      </p:sp>
+      <p:sp>
+        <p:nvSpPr>
+          <p:cNvPr id="50" name="TextBox 49"/>
+          <p:cNvSpPr txBox="1"/>
+          <p:nvPr/>
+        </p:nvSpPr>
+        <p:spPr>
+          <a:xfrm>
+            <a:off x="6766560" y="6217920"/>
+            <a:ext cx="4114800" cy="228600"/>
+          </a:xfrm>
+          <a:prstGeom prst="rect">
+            <a:avLst/>
+          </a:prstGeom>
+          <a:noFill/>
+        </p:spPr>
+        <p:txBody>
+          <a:bodyPr wrap="square">
+            <a:spAutoFit/>
+          </a:bodyPr>
+          <a:lstStyle/>
+          <a:p>
+            <a:pPr algn="l">
+              <a:defRPr sz="1000" b="0">
+                <a:solidFill>
+                  <a:srgbClr val="BBBBCC"/>
+                </a:solidFill>
+                <a:latin typeface="Consolas"/>
+              </a:defRPr>
+            </a:pPr>
+            <a:r>
+              <a:t>PR opened         →  reviewers, linked story, diff</a:t>
+            </a:r>
+          </a:p>
+        </p:txBody>
+      </p:sp>
+      <p:sp>
+        <p:nvSpPr>
+          <p:cNvPr id="51" name="TextBox 50"/>
+          <p:cNvSpPr txBox="1"/>
+          <p:nvPr/>
+        </p:nvSpPr>
+        <p:spPr>
+          <a:xfrm>
+            <a:off x="6766560" y="6446520"/>
+            <a:ext cx="4114800" cy="228600"/>
+          </a:xfrm>
+          <a:prstGeom prst="rect">
+            <a:avLst/>
+          </a:prstGeom>
+          <a:noFill/>
+        </p:spPr>
+        <p:txBody>
+          <a:bodyPr wrap="square">
+            <a:spAutoFit/>
+          </a:bodyPr>
+          <a:lstStyle/>
+          <a:p>
+            <a:pPr algn="l">
+              <a:defRPr sz="1000" b="0">
+                <a:solidFill>
+                  <a:srgbClr val="BBBBCC"/>
+                </a:solidFill>
+                <a:latin typeface="Consolas"/>
+              </a:defRPr>
+            </a:pPr>
+            <a:r>
+              <a:t>PR merged         →  approval, final state of work</a:t>
+            </a:r>
+          </a:p>
+        </p:txBody>
+      </p:sp>
+      <p:sp>
+        <p:nvSpPr>
+          <p:cNvPr id="52" name="TextBox 51"/>
+          <p:cNvSpPr txBox="1"/>
+          <p:nvPr/>
+        </p:nvSpPr>
+        <p:spPr>
+          <a:xfrm>
+            <a:off x="6766560" y="6675120"/>
+            <a:ext cx="4114800" cy="228600"/>
+          </a:xfrm>
+          <a:prstGeom prst="rect">
+            <a:avLst/>
+          </a:prstGeom>
+          <a:noFill/>
+        </p:spPr>
+        <p:txBody>
+          <a:bodyPr wrap="square">
+            <a:spAutoFit/>
+          </a:bodyPr>
+          <a:lstStyle/>
+          <a:p>
+            <a:pPr algn="l">
+              <a:defRPr sz="1000" b="0">
+                <a:solidFill>
+                  <a:srgbClr val="BBBBCC"/>
+                </a:solidFill>
+                <a:latin typeface="Consolas"/>
+              </a:defRPr>
+            </a:pPr>
+            <a:r>
+              <a:t>Branch deleted  →  when, by whom, merge status</a:t>
+            </a:r>
+          </a:p>
+        </p:txBody>
+      </p:sp>
+      <p:sp>
+        <p:nvSpPr>
+          <p:cNvPr id="53" name="TextBox 52"/>
+          <p:cNvSpPr txBox="1"/>
+          <p:nvPr/>
+        </p:nvSpPr>
+        <p:spPr>
+          <a:xfrm>
+            <a:off x="11155680" y="6400800"/>
+            <a:ext cx="914400" cy="365760"/>
+          </a:xfrm>
+          <a:prstGeom prst="rect">
+            <a:avLst/>
+          </a:prstGeom>
+          <a:noFill/>
+        </p:spPr>
+        <p:txBody>
+          <a:bodyPr wrap="square">
+            <a:spAutoFit/>
+          </a:bodyPr>
+          <a:lstStyle/>
+          <a:p>
+            <a:pPr algn="r">
+              <a:defRPr sz="1100" b="0">
+                <a:solidFill>
+                  <a:srgbClr val="888899"/>
+                </a:solidFill>
+                <a:latin typeface="Calibri"/>
+              </a:defRPr>
+            </a:pPr>
+            <a:r>
+              <a:t>17 / 17</a:t>
             </a:r>
           </a:p>
         </p:txBody>
@@ -13073,7 +17552,7 @@
               </a:defRPr>
             </a:pPr>
             <a:r>
-              <a:t>2 / 15</a:t>
+              <a:t>2 / 17</a:t>
             </a:r>
           </a:p>
         </p:txBody>
@@ -14140,7 +18619,7 @@
               </a:defRPr>
             </a:pPr>
             <a:r>
-              <a:t>3 / 15</a:t>
+              <a:t>3 / 17</a:t>
             </a:r>
           </a:p>
         </p:txBody>
@@ -15373,7 +19852,7 @@
               </a:defRPr>
             </a:pPr>
             <a:r>
-              <a:t>4 / 15</a:t>
+              <a:t>4 / 17</a:t>
             </a:r>
           </a:p>
         </p:txBody>
@@ -16884,7 +21363,7 @@
               </a:defRPr>
             </a:pPr>
             <a:r>
-              <a:t>5 / 15</a:t>
+              <a:t>5 / 17</a:t>
             </a:r>
           </a:p>
         </p:txBody>
@@ -17817,7 +22296,7 @@
               </a:defRPr>
             </a:pPr>
             <a:r>
-              <a:t>6 / 15</a:t>
+              <a:t>6 / 17</a:t>
             </a:r>
           </a:p>
         </p:txBody>
@@ -19475,7 +23954,7 @@
               </a:defRPr>
             </a:pPr>
             <a:r>
-              <a:t>7 / 15</a:t>
+              <a:t>7 / 17</a:t>
             </a:r>
           </a:p>
         </p:txBody>
@@ -21238,7 +25717,7 @@
               </a:defRPr>
             </a:pPr>
             <a:r>
-              <a:t>8 / 15</a:t>
+              <a:t>8 / 17</a:t>
             </a:r>
           </a:p>
         </p:txBody>
@@ -23365,7 +27844,7 @@
               </a:defRPr>
             </a:pPr>
             <a:r>
-              <a:t>9 / 15</a:t>
+              <a:t>9 / 17</a:t>
             </a:r>
           </a:p>
         </p:txBody>

</xml_diff>